<commit_message>
Rebrand: Master in Business Analytics and Data Science, MBDS-PT2026F, IE logo
</commit_message>
<xml_diff>
--- a/2026-27/S03/MLOps_S03_Pipelines_Environments_Security.pptx
+++ b/2026-27/S03/MLOps_S03_Pipelines_Environments_Security.pptx
@@ -4255,7 +4255,7 @@
                 <a:ea typeface="Calibri" pitchFamily="34" charset="-122"/>
                 <a:cs typeface="Calibri" pitchFamily="34" charset="-120"/>
               </a:rPr>
-              <a:t>Master in Business Analytics and Big Data</a:t>
+              <a:t>Master in Business Analytics and Data Science</a:t>
             </a:r>
             <a:endParaRPr lang="en-US" sz="900" dirty="0"/>
           </a:p>
@@ -4294,7 +4294,7 @@
                 <a:ea typeface="Calibri" pitchFamily="34" charset="-122"/>
                 <a:cs typeface="Calibri" pitchFamily="34" charset="-120"/>
               </a:rPr>
-              <a:t>MLOps · MBABD-PT 2026–27 · Session 3 · Juan Ramírez</a:t>
+              <a:t>MLOps · MBDS-PT2026F · Session 3 · Juan Ramírez</a:t>
             </a:r>
             <a:endParaRPr lang="en-US" sz="800" dirty="0"/>
           </a:p>
@@ -4560,6 +4560,10 @@
             <a:prstDash val="solid"/>
           </a:ln>
         </p:spPr>
+        <p:txBody>
+          <a:bodyPr/>
+          <a:p/>
+        </p:txBody>
       </p:sp>
       <p:sp>
         <p:nvSpPr>
@@ -4626,6 +4630,10 @@
             <a:prstDash val="solid"/>
           </a:ln>
         </p:spPr>
+        <p:txBody>
+          <a:bodyPr/>
+          <a:p/>
+        </p:txBody>
       </p:sp>
       <p:sp>
         <p:nvSpPr>
@@ -4692,6 +4700,10 @@
             <a:prstDash val="solid"/>
           </a:ln>
         </p:spPr>
+        <p:txBody>
+          <a:bodyPr/>
+          <a:p/>
+        </p:txBody>
       </p:sp>
       <p:sp>
         <p:nvSpPr>
@@ -4758,6 +4770,10 @@
             <a:prstDash val="solid"/>
           </a:ln>
         </p:spPr>
+        <p:txBody>
+          <a:bodyPr/>
+          <a:p/>
+        </p:txBody>
       </p:sp>
       <p:sp>
         <p:nvSpPr>
@@ -4824,6 +4840,10 @@
             <a:prstDash val="solid"/>
           </a:ln>
         </p:spPr>
+        <p:txBody>
+          <a:bodyPr/>
+          <a:p/>
+        </p:txBody>
       </p:sp>
       <p:sp>
         <p:nvSpPr>
@@ -4890,6 +4910,10 @@
             <a:prstDash val="solid"/>
           </a:ln>
         </p:spPr>
+        <p:txBody>
+          <a:bodyPr/>
+          <a:p/>
+        </p:txBody>
       </p:sp>
       <p:sp>
         <p:nvSpPr>
@@ -4956,6 +4980,10 @@
             <a:prstDash val="solid"/>
           </a:ln>
         </p:spPr>
+        <p:txBody>
+          <a:bodyPr/>
+          <a:p/>
+        </p:txBody>
       </p:sp>
       <p:sp>
         <p:nvSpPr>
@@ -5022,6 +5050,10 @@
             <a:prstDash val="solid"/>
           </a:ln>
         </p:spPr>
+        <p:txBody>
+          <a:bodyPr/>
+          <a:p/>
+        </p:txBody>
       </p:sp>
       <p:sp>
         <p:nvSpPr>
@@ -5088,6 +5120,10 @@
             <a:prstDash val="solid"/>
           </a:ln>
         </p:spPr>
+        <p:txBody>
+          <a:bodyPr/>
+          <a:p/>
+        </p:txBody>
       </p:sp>
       <p:sp>
         <p:nvSpPr>
@@ -5128,6 +5164,30 @@
           </a:p>
         </p:txBody>
       </p:sp>
+      <p:pic>
+        <p:nvPicPr>
+          <p:cNvPr id="28" name="IE University logo" descr="IE University, School of Science &amp; Technology"/>
+          <p:cNvPicPr>
+            <a:picLocks noChangeAspect="1"/>
+          </p:cNvPicPr>
+          <p:nvPr/>
+        </p:nvPicPr>
+        <p:blipFill>
+          <a:blip r:embed="rId3"/>
+          <a:stretch>
+            <a:fillRect/>
+          </a:stretch>
+        </p:blipFill>
+        <p:spPr>
+          <a:xfrm>
+            <a:off x="8252653" y="109728"/>
+            <a:ext cx="525587" cy="704395"/>
+          </a:xfrm>
+          <a:prstGeom prst="rect">
+            <a:avLst/>
+          </a:prstGeom>
+        </p:spPr>
+      </p:pic>
     </p:spTree>
   </p:cSld>
   <p:clrMapOvr>
@@ -5193,7 +5253,7 @@
                 <a:ea typeface="Calibri" pitchFamily="34" charset="-122"/>
                 <a:cs typeface="Calibri" pitchFamily="34" charset="-120"/>
               </a:rPr>
-              <a:t>Master in Business Analytics and Big Data</a:t>
+              <a:t>Master in Business Analytics and Data Science</a:t>
             </a:r>
             <a:endParaRPr lang="en-US" sz="900" dirty="0"/>
           </a:p>
@@ -5232,7 +5292,7 @@
                 <a:ea typeface="Calibri" pitchFamily="34" charset="-122"/>
                 <a:cs typeface="Calibri" pitchFamily="34" charset="-120"/>
               </a:rPr>
-              <a:t>MLOps · MBABD-PT 2026–27 · Session 3 · Juan Ramírez</a:t>
+              <a:t>MLOps · MBDS-PT2026F · Session 3 · Juan Ramírez</a:t>
             </a:r>
             <a:endParaRPr lang="en-US" sz="800" dirty="0"/>
           </a:p>
@@ -5340,6 +5400,10 @@
             <a:prstDash val="solid"/>
           </a:ln>
         </p:spPr>
+        <p:txBody>
+          <a:bodyPr/>
+          <a:p/>
+        </p:txBody>
       </p:sp>
       <p:pic>
         <p:nvPicPr>
@@ -5467,6 +5531,10 @@
             <a:prstDash val="solid"/>
           </a:ln>
         </p:spPr>
+        <p:txBody>
+          <a:bodyPr/>
+          <a:p/>
+        </p:txBody>
       </p:sp>
       <p:pic>
         <p:nvPicPr>
@@ -5594,6 +5662,10 @@
             <a:prstDash val="solid"/>
           </a:ln>
         </p:spPr>
+        <p:txBody>
+          <a:bodyPr/>
+          <a:p/>
+        </p:txBody>
       </p:sp>
       <p:pic>
         <p:nvPicPr>
@@ -5721,6 +5793,10 @@
             <a:prstDash val="solid"/>
           </a:ln>
         </p:spPr>
+        <p:txBody>
+          <a:bodyPr/>
+          <a:p/>
+        </p:txBody>
       </p:sp>
       <p:pic>
         <p:nvPicPr>
@@ -5848,6 +5924,10 @@
             <a:prstDash val="solid"/>
           </a:ln>
         </p:spPr>
+        <p:txBody>
+          <a:bodyPr/>
+          <a:p/>
+        </p:txBody>
       </p:sp>
       <p:pic>
         <p:nvPicPr>
@@ -5975,6 +6055,10 @@
             <a:prstDash val="solid"/>
           </a:ln>
         </p:spPr>
+        <p:txBody>
+          <a:bodyPr/>
+          <a:p/>
+        </p:txBody>
       </p:sp>
       <p:pic>
         <p:nvPicPr>
@@ -6104,6 +6188,10 @@
             <a:prstDash val="solid"/>
           </a:ln>
         </p:spPr>
+        <p:txBody>
+          <a:bodyPr/>
+          <a:p/>
+        </p:txBody>
       </p:sp>
       <p:pic>
         <p:nvPicPr>
@@ -6168,6 +6256,30 @@
           </a:p>
         </p:txBody>
       </p:sp>
+      <p:pic>
+        <p:nvPicPr>
+          <p:cNvPr id="34" name="IE University logo" descr="IE University, School of Science &amp; Technology"/>
+          <p:cNvPicPr>
+            <a:picLocks noChangeAspect="1"/>
+          </p:cNvPicPr>
+          <p:nvPr/>
+        </p:nvPicPr>
+        <p:blipFill>
+          <a:blip r:embed="rId10"/>
+          <a:stretch>
+            <a:fillRect/>
+          </a:stretch>
+        </p:blipFill>
+        <p:spPr>
+          <a:xfrm>
+            <a:off x="8013607" y="92634"/>
+            <a:ext cx="764633" cy="262789"/>
+          </a:xfrm>
+          <a:prstGeom prst="rect">
+            <a:avLst/>
+          </a:prstGeom>
+        </p:spPr>
+      </p:pic>
     </p:spTree>
   </p:cSld>
   <p:clrMapOvr>
@@ -6233,7 +6345,7 @@
                 <a:ea typeface="Calibri" pitchFamily="34" charset="-122"/>
                 <a:cs typeface="Calibri" pitchFamily="34" charset="-120"/>
               </a:rPr>
-              <a:t>Master in Business Analytics and Big Data</a:t>
+              <a:t>Master in Business Analytics and Data Science</a:t>
             </a:r>
             <a:endParaRPr lang="en-US" sz="900" dirty="0"/>
           </a:p>
@@ -6272,7 +6384,7 @@
                 <a:ea typeface="Calibri" pitchFamily="34" charset="-122"/>
                 <a:cs typeface="Calibri" pitchFamily="34" charset="-120"/>
               </a:rPr>
-              <a:t>MLOps · MBABD-PT 2026–27 · Session 3 · Juan Ramírez</a:t>
+              <a:t>MLOps · MBDS-PT2026F · Session 3 · Juan Ramírez</a:t>
             </a:r>
             <a:endParaRPr lang="en-US" sz="800" dirty="0"/>
           </a:p>
@@ -6382,6 +6494,10 @@
             <a:prstDash val="solid"/>
           </a:ln>
         </p:spPr>
+        <p:txBody>
+          <a:bodyPr/>
+          <a:p/>
+        </p:txBody>
       </p:sp>
       <p:sp>
         <p:nvSpPr>
@@ -6407,6 +6523,10 @@
             <a:prstDash val="solid"/>
           </a:ln>
         </p:spPr>
+        <p:txBody>
+          <a:bodyPr/>
+          <a:p/>
+        </p:txBody>
       </p:sp>
       <p:pic>
         <p:nvPicPr>
@@ -6582,6 +6702,10 @@
             <a:prstDash val="solid"/>
           </a:ln>
         </p:spPr>
+        <p:txBody>
+          <a:bodyPr/>
+          <a:p/>
+        </p:txBody>
       </p:sp>
       <p:sp>
         <p:nvSpPr>
@@ -6607,6 +6731,10 @@
             <a:prstDash val="solid"/>
           </a:ln>
         </p:spPr>
+        <p:txBody>
+          <a:bodyPr/>
+          <a:p/>
+        </p:txBody>
       </p:sp>
       <p:pic>
         <p:nvPicPr>
@@ -6782,6 +6910,10 @@
             <a:prstDash val="solid"/>
           </a:ln>
         </p:spPr>
+        <p:txBody>
+          <a:bodyPr/>
+          <a:p/>
+        </p:txBody>
       </p:sp>
       <p:pic>
         <p:nvPicPr>
@@ -6846,6 +6978,30 @@
           </a:p>
         </p:txBody>
       </p:sp>
+      <p:pic>
+        <p:nvPicPr>
+          <p:cNvPr id="20" name="IE University logo" descr="IE University, School of Science &amp; Technology"/>
+          <p:cNvPicPr>
+            <a:picLocks noChangeAspect="1"/>
+          </p:cNvPicPr>
+          <p:nvPr/>
+        </p:nvPicPr>
+        <p:blipFill>
+          <a:blip r:embed="rId6"/>
+          <a:stretch>
+            <a:fillRect/>
+          </a:stretch>
+        </p:blipFill>
+        <p:spPr>
+          <a:xfrm>
+            <a:off x="8013607" y="92634"/>
+            <a:ext cx="764633" cy="262789"/>
+          </a:xfrm>
+          <a:prstGeom prst="rect">
+            <a:avLst/>
+          </a:prstGeom>
+        </p:spPr>
+      </p:pic>
     </p:spTree>
   </p:cSld>
   <p:clrMapOvr>
@@ -6911,7 +7067,7 @@
                 <a:ea typeface="Calibri" pitchFamily="34" charset="-122"/>
                 <a:cs typeface="Calibri" pitchFamily="34" charset="-120"/>
               </a:rPr>
-              <a:t>Master in Business Analytics and Big Data</a:t>
+              <a:t>Master in Business Analytics and Data Science</a:t>
             </a:r>
             <a:endParaRPr lang="en-US" sz="900" dirty="0"/>
           </a:p>
@@ -6950,7 +7106,7 @@
                 <a:ea typeface="Calibri" pitchFamily="34" charset="-122"/>
                 <a:cs typeface="Calibri" pitchFamily="34" charset="-120"/>
               </a:rPr>
-              <a:t>MLOps · MBABD-PT 2026–27 · Session 3 · Juan Ramírez</a:t>
+              <a:t>MLOps · MBDS-PT2026F · Session 3 · Juan Ramírez</a:t>
             </a:r>
             <a:endParaRPr lang="en-US" sz="800" dirty="0"/>
           </a:p>
@@ -7060,6 +7216,10 @@
             <a:prstDash val="solid"/>
           </a:ln>
         </p:spPr>
+        <p:txBody>
+          <a:bodyPr/>
+          <a:p/>
+        </p:txBody>
       </p:sp>
       <p:sp>
         <p:nvSpPr>
@@ -7085,6 +7245,10 @@
             <a:prstDash val="solid"/>
           </a:ln>
         </p:spPr>
+        <p:txBody>
+          <a:bodyPr/>
+          <a:p/>
+        </p:txBody>
       </p:sp>
       <p:pic>
         <p:nvPicPr>
@@ -7239,6 +7403,10 @@
             <a:prstDash val="solid"/>
           </a:ln>
         </p:spPr>
+        <p:txBody>
+          <a:bodyPr/>
+          <a:p/>
+        </p:txBody>
       </p:sp>
       <p:sp>
         <p:nvSpPr>
@@ -7264,6 +7432,10 @@
             <a:prstDash val="solid"/>
           </a:ln>
         </p:spPr>
+        <p:txBody>
+          <a:bodyPr/>
+          <a:p/>
+        </p:txBody>
       </p:sp>
       <p:pic>
         <p:nvPicPr>
@@ -7418,6 +7590,10 @@
             <a:prstDash val="solid"/>
           </a:ln>
         </p:spPr>
+        <p:txBody>
+          <a:bodyPr/>
+          <a:p/>
+        </p:txBody>
       </p:sp>
       <p:sp>
         <p:nvSpPr>
@@ -7443,6 +7619,10 @@
             <a:prstDash val="solid"/>
           </a:ln>
         </p:spPr>
+        <p:txBody>
+          <a:bodyPr/>
+          <a:p/>
+        </p:txBody>
       </p:sp>
       <p:pic>
         <p:nvPicPr>
@@ -7597,6 +7777,10 @@
             <a:prstDash val="solid"/>
           </a:ln>
         </p:spPr>
+        <p:txBody>
+          <a:bodyPr/>
+          <a:p/>
+        </p:txBody>
       </p:sp>
       <p:pic>
         <p:nvPicPr>
@@ -7661,6 +7845,30 @@
           </a:p>
         </p:txBody>
       </p:sp>
+      <p:pic>
+        <p:nvPicPr>
+          <p:cNvPr id="25" name="IE University logo" descr="IE University, School of Science &amp; Technology"/>
+          <p:cNvPicPr>
+            <a:picLocks noChangeAspect="1"/>
+          </p:cNvPicPr>
+          <p:nvPr/>
+        </p:nvPicPr>
+        <p:blipFill>
+          <a:blip r:embed="rId7"/>
+          <a:stretch>
+            <a:fillRect/>
+          </a:stretch>
+        </p:blipFill>
+        <p:spPr>
+          <a:xfrm>
+            <a:off x="8013607" y="92634"/>
+            <a:ext cx="764633" cy="262789"/>
+          </a:xfrm>
+          <a:prstGeom prst="rect">
+            <a:avLst/>
+          </a:prstGeom>
+        </p:spPr>
+      </p:pic>
     </p:spTree>
   </p:cSld>
   <p:clrMapOvr>
@@ -7726,7 +7934,7 @@
                 <a:ea typeface="Calibri" pitchFamily="34" charset="-122"/>
                 <a:cs typeface="Calibri" pitchFamily="34" charset="-120"/>
               </a:rPr>
-              <a:t>Master in Business Analytics and Big Data</a:t>
+              <a:t>Master in Business Analytics and Data Science</a:t>
             </a:r>
             <a:endParaRPr lang="en-US" sz="900" dirty="0"/>
           </a:p>
@@ -7765,7 +7973,7 @@
                 <a:ea typeface="Calibri" pitchFamily="34" charset="-122"/>
                 <a:cs typeface="Calibri" pitchFamily="34" charset="-120"/>
               </a:rPr>
-              <a:t>MLOps · MBABD-PT 2026–27 · Session 3 · Juan Ramírez</a:t>
+              <a:t>MLOps · MBDS-PT2026F · Session 3 · Juan Ramírez</a:t>
             </a:r>
             <a:endParaRPr lang="en-US" sz="800" dirty="0"/>
           </a:p>
@@ -7873,6 +8081,10 @@
             <a:prstDash val="solid"/>
           </a:ln>
         </p:spPr>
+        <p:txBody>
+          <a:bodyPr/>
+          <a:p/>
+        </p:txBody>
       </p:sp>
       <p:sp>
         <p:nvSpPr>
@@ -8015,6 +8227,10 @@
             <a:prstDash val="solid"/>
           </a:ln>
         </p:spPr>
+        <p:txBody>
+          <a:bodyPr/>
+          <a:p/>
+        </p:txBody>
       </p:sp>
       <p:sp>
         <p:nvSpPr>
@@ -8157,6 +8373,10 @@
             <a:prstDash val="solid"/>
           </a:ln>
         </p:spPr>
+        <p:txBody>
+          <a:bodyPr/>
+          <a:p/>
+        </p:txBody>
       </p:sp>
       <p:sp>
         <p:nvSpPr>
@@ -8301,6 +8521,10 @@
             <a:prstDash val="solid"/>
           </a:ln>
         </p:spPr>
+        <p:txBody>
+          <a:bodyPr/>
+          <a:p/>
+        </p:txBody>
       </p:sp>
       <p:pic>
         <p:nvPicPr>
@@ -8365,6 +8589,30 @@
           </a:p>
         </p:txBody>
       </p:sp>
+      <p:pic>
+        <p:nvPicPr>
+          <p:cNvPr id="22" name="IE University logo" descr="IE University, School of Science &amp; Technology"/>
+          <p:cNvPicPr>
+            <a:picLocks noChangeAspect="1"/>
+          </p:cNvPicPr>
+          <p:nvPr/>
+        </p:nvPicPr>
+        <p:blipFill>
+          <a:blip r:embed="rId4"/>
+          <a:stretch>
+            <a:fillRect/>
+          </a:stretch>
+        </p:blipFill>
+        <p:spPr>
+          <a:xfrm>
+            <a:off x="8013607" y="92634"/>
+            <a:ext cx="764633" cy="262789"/>
+          </a:xfrm>
+          <a:prstGeom prst="rect">
+            <a:avLst/>
+          </a:prstGeom>
+        </p:spPr>
+      </p:pic>
     </p:spTree>
   </p:cSld>
   <p:clrMapOvr>
@@ -8430,7 +8678,7 @@
                 <a:ea typeface="Calibri" pitchFamily="34" charset="-122"/>
                 <a:cs typeface="Calibri" pitchFamily="34" charset="-120"/>
               </a:rPr>
-              <a:t>Master in Business Analytics and Big Data</a:t>
+              <a:t>Master in Business Analytics and Data Science</a:t>
             </a:r>
             <a:endParaRPr lang="en-US" sz="900" dirty="0"/>
           </a:p>
@@ -8469,7 +8717,7 @@
                 <a:ea typeface="Calibri" pitchFamily="34" charset="-122"/>
                 <a:cs typeface="Calibri" pitchFamily="34" charset="-120"/>
               </a:rPr>
-              <a:t>MLOps · MBABD-PT 2026–27 · Session 3 · Juan Ramírez</a:t>
+              <a:t>MLOps · MBDS-PT2026F · Session 3 · Juan Ramírez</a:t>
             </a:r>
             <a:endParaRPr lang="en-US" sz="800" dirty="0"/>
           </a:p>
@@ -8579,6 +8827,10 @@
             <a:prstDash val="solid"/>
           </a:ln>
         </p:spPr>
+        <p:txBody>
+          <a:bodyPr/>
+          <a:p/>
+        </p:txBody>
       </p:sp>
       <p:sp>
         <p:nvSpPr>
@@ -8604,6 +8856,10 @@
             <a:prstDash val="solid"/>
           </a:ln>
         </p:spPr>
+        <p:txBody>
+          <a:bodyPr/>
+          <a:p/>
+        </p:txBody>
       </p:sp>
       <p:pic>
         <p:nvPicPr>
@@ -8758,6 +9014,10 @@
             <a:prstDash val="solid"/>
           </a:ln>
         </p:spPr>
+        <p:txBody>
+          <a:bodyPr/>
+          <a:p/>
+        </p:txBody>
       </p:sp>
       <p:sp>
         <p:nvSpPr>
@@ -8783,6 +9043,10 @@
             <a:prstDash val="solid"/>
           </a:ln>
         </p:spPr>
+        <p:txBody>
+          <a:bodyPr/>
+          <a:p/>
+        </p:txBody>
       </p:sp>
       <p:pic>
         <p:nvPicPr>
@@ -8976,6 +9240,10 @@
             <a:prstDash val="solid"/>
           </a:ln>
         </p:spPr>
+        <p:txBody>
+          <a:bodyPr/>
+          <a:p/>
+        </p:txBody>
       </p:sp>
       <p:sp>
         <p:nvSpPr>
@@ -9039,6 +9307,10 @@
             <a:tailEnd type="triangle"/>
           </a:ln>
         </p:spPr>
+        <p:txBody>
+          <a:bodyPr/>
+          <a:p/>
+        </p:txBody>
       </p:sp>
       <p:sp>
         <p:nvSpPr>
@@ -9066,6 +9338,10 @@
             <a:prstDash val="solid"/>
           </a:ln>
         </p:spPr>
+        <p:txBody>
+          <a:bodyPr/>
+          <a:p/>
+        </p:txBody>
       </p:sp>
       <p:sp>
         <p:nvSpPr>
@@ -9129,6 +9405,10 @@
             <a:tailEnd type="triangle"/>
           </a:ln>
         </p:spPr>
+        <p:txBody>
+          <a:bodyPr/>
+          <a:p/>
+        </p:txBody>
       </p:sp>
       <p:sp>
         <p:nvSpPr>
@@ -9156,6 +9436,10 @@
             <a:prstDash val="solid"/>
           </a:ln>
         </p:spPr>
+        <p:txBody>
+          <a:bodyPr/>
+          <a:p/>
+        </p:txBody>
       </p:sp>
       <p:sp>
         <p:nvSpPr>
@@ -9219,6 +9503,10 @@
             <a:tailEnd type="triangle"/>
           </a:ln>
         </p:spPr>
+        <p:txBody>
+          <a:bodyPr/>
+          <a:p/>
+        </p:txBody>
       </p:sp>
       <p:sp>
         <p:nvSpPr>
@@ -9243,6 +9531,10 @@
             <a:tailEnd type="triangle"/>
           </a:ln>
         </p:spPr>
+        <p:txBody>
+          <a:bodyPr/>
+          <a:p/>
+        </p:txBody>
       </p:sp>
       <p:sp>
         <p:nvSpPr>
@@ -9270,6 +9562,10 @@
             <a:prstDash val="solid"/>
           </a:ln>
         </p:spPr>
+        <p:txBody>
+          <a:bodyPr/>
+          <a:p/>
+        </p:txBody>
       </p:sp>
       <p:sp>
         <p:nvSpPr>
@@ -9336,6 +9632,10 @@
             <a:prstDash val="solid"/>
           </a:ln>
         </p:spPr>
+        <p:txBody>
+          <a:bodyPr/>
+          <a:p/>
+        </p:txBody>
       </p:sp>
       <p:sp>
         <p:nvSpPr>
@@ -9415,6 +9715,30 @@
           </a:p>
         </p:txBody>
       </p:sp>
+      <p:pic>
+        <p:nvPicPr>
+          <p:cNvPr id="33" name="IE University logo" descr="IE University, School of Science &amp; Technology"/>
+          <p:cNvPicPr>
+            <a:picLocks noChangeAspect="1"/>
+          </p:cNvPicPr>
+          <p:nvPr/>
+        </p:nvPicPr>
+        <p:blipFill>
+          <a:blip r:embed="rId5"/>
+          <a:stretch>
+            <a:fillRect/>
+          </a:stretch>
+        </p:blipFill>
+        <p:spPr>
+          <a:xfrm>
+            <a:off x="8013607" y="92634"/>
+            <a:ext cx="764633" cy="262789"/>
+          </a:xfrm>
+          <a:prstGeom prst="rect">
+            <a:avLst/>
+          </a:prstGeom>
+        </p:spPr>
+      </p:pic>
     </p:spTree>
   </p:cSld>
   <p:clrMapOvr>
@@ -9480,7 +9804,7 @@
                 <a:ea typeface="Calibri" pitchFamily="34" charset="-122"/>
                 <a:cs typeface="Calibri" pitchFamily="34" charset="-120"/>
               </a:rPr>
-              <a:t>Master in Business Analytics and Big Data</a:t>
+              <a:t>Master in Business Analytics and Data Science</a:t>
             </a:r>
             <a:endParaRPr lang="en-US" sz="900" dirty="0"/>
           </a:p>
@@ -9519,7 +9843,7 @@
                 <a:ea typeface="Calibri" pitchFamily="34" charset="-122"/>
                 <a:cs typeface="Calibri" pitchFamily="34" charset="-120"/>
               </a:rPr>
-              <a:t>MLOps · MBABD-PT 2026–27 · Session 3 · Juan Ramírez</a:t>
+              <a:t>MLOps · MBDS-PT2026F · Session 3 · Juan Ramírez</a:t>
             </a:r>
             <a:endParaRPr lang="en-US" sz="800" dirty="0"/>
           </a:p>
@@ -9627,6 +9951,10 @@
             <a:prstDash val="solid"/>
           </a:ln>
         </p:spPr>
+        <p:txBody>
+          <a:bodyPr/>
+          <a:p/>
+        </p:txBody>
       </p:sp>
       <p:pic>
         <p:nvPicPr>
@@ -9754,6 +10082,10 @@
             <a:prstDash val="solid"/>
           </a:ln>
         </p:spPr>
+        <p:txBody>
+          <a:bodyPr/>
+          <a:p/>
+        </p:txBody>
       </p:sp>
       <p:pic>
         <p:nvPicPr>
@@ -9881,6 +10213,10 @@
             <a:prstDash val="solid"/>
           </a:ln>
         </p:spPr>
+        <p:txBody>
+          <a:bodyPr/>
+          <a:p/>
+        </p:txBody>
       </p:sp>
       <p:pic>
         <p:nvPicPr>
@@ -10010,6 +10346,10 @@
             <a:prstDash val="solid"/>
           </a:ln>
         </p:spPr>
+        <p:txBody>
+          <a:bodyPr/>
+          <a:p/>
+        </p:txBody>
       </p:sp>
       <p:pic>
         <p:nvPicPr>
@@ -10113,6 +10453,30 @@
           </a:p>
         </p:txBody>
       </p:sp>
+      <p:pic>
+        <p:nvPicPr>
+          <p:cNvPr id="23" name="IE University logo" descr="IE University, School of Science &amp; Technology"/>
+          <p:cNvPicPr>
+            <a:picLocks noChangeAspect="1"/>
+          </p:cNvPicPr>
+          <p:nvPr/>
+        </p:nvPicPr>
+        <p:blipFill>
+          <a:blip r:embed="rId7"/>
+          <a:stretch>
+            <a:fillRect/>
+          </a:stretch>
+        </p:blipFill>
+        <p:spPr>
+          <a:xfrm>
+            <a:off x="8013607" y="92634"/>
+            <a:ext cx="764633" cy="262789"/>
+          </a:xfrm>
+          <a:prstGeom prst="rect">
+            <a:avLst/>
+          </a:prstGeom>
+        </p:spPr>
+      </p:pic>
     </p:spTree>
   </p:cSld>
   <p:clrMapOvr>
@@ -10178,7 +10542,7 @@
                 <a:ea typeface="Calibri" pitchFamily="34" charset="-122"/>
                 <a:cs typeface="Calibri" pitchFamily="34" charset="-120"/>
               </a:rPr>
-              <a:t>Master in Business Analytics and Big Data</a:t>
+              <a:t>Master in Business Analytics and Data Science</a:t>
             </a:r>
             <a:endParaRPr lang="en-US" sz="900" dirty="0"/>
           </a:p>
@@ -10217,7 +10581,7 @@
                 <a:ea typeface="Calibri" pitchFamily="34" charset="-122"/>
                 <a:cs typeface="Calibri" pitchFamily="34" charset="-120"/>
               </a:rPr>
-              <a:t>MLOps · MBABD-PT 2026–27 · Session 3 · Juan Ramírez</a:t>
+              <a:t>MLOps · MBDS-PT2026F · Session 3 · Juan Ramírez</a:t>
             </a:r>
             <a:endParaRPr lang="en-US" sz="800" dirty="0"/>
           </a:p>
@@ -10327,6 +10691,10 @@
             <a:prstDash val="solid"/>
           </a:ln>
         </p:spPr>
+        <p:txBody>
+          <a:bodyPr/>
+          <a:p/>
+        </p:txBody>
       </p:sp>
       <p:sp>
         <p:nvSpPr>
@@ -10352,6 +10720,10 @@
             <a:prstDash val="solid"/>
           </a:ln>
         </p:spPr>
+        <p:txBody>
+          <a:bodyPr/>
+          <a:p/>
+        </p:txBody>
       </p:sp>
       <p:pic>
         <p:nvPicPr>
@@ -10481,6 +10853,10 @@
             <a:prstDash val="solid"/>
           </a:ln>
         </p:spPr>
+        <p:txBody>
+          <a:bodyPr/>
+          <a:p/>
+        </p:txBody>
       </p:sp>
       <p:sp>
         <p:nvSpPr>
@@ -10506,6 +10882,10 @@
             <a:prstDash val="solid"/>
           </a:ln>
         </p:spPr>
+        <p:txBody>
+          <a:bodyPr/>
+          <a:p/>
+        </p:txBody>
       </p:sp>
       <p:pic>
         <p:nvPicPr>
@@ -10635,6 +11015,10 @@
             <a:prstDash val="solid"/>
           </a:ln>
         </p:spPr>
+        <p:txBody>
+          <a:bodyPr/>
+          <a:p/>
+        </p:txBody>
       </p:sp>
       <p:sp>
         <p:nvSpPr>
@@ -10660,6 +11044,10 @@
             <a:prstDash val="solid"/>
           </a:ln>
         </p:spPr>
+        <p:txBody>
+          <a:bodyPr/>
+          <a:p/>
+        </p:txBody>
       </p:sp>
       <p:pic>
         <p:nvPicPr>
@@ -10789,6 +11177,10 @@
             <a:prstDash val="solid"/>
           </a:ln>
         </p:spPr>
+        <p:txBody>
+          <a:bodyPr/>
+          <a:p/>
+        </p:txBody>
       </p:sp>
       <p:pic>
         <p:nvPicPr>
@@ -10853,6 +11245,30 @@
           </a:p>
         </p:txBody>
       </p:sp>
+      <p:pic>
+        <p:nvPicPr>
+          <p:cNvPr id="25" name="IE University logo" descr="IE University, School of Science &amp; Technology"/>
+          <p:cNvPicPr>
+            <a:picLocks noChangeAspect="1"/>
+          </p:cNvPicPr>
+          <p:nvPr/>
+        </p:nvPicPr>
+        <p:blipFill>
+          <a:blip r:embed="rId7"/>
+          <a:stretch>
+            <a:fillRect/>
+          </a:stretch>
+        </p:blipFill>
+        <p:spPr>
+          <a:xfrm>
+            <a:off x="8013607" y="92634"/>
+            <a:ext cx="764633" cy="262789"/>
+          </a:xfrm>
+          <a:prstGeom prst="rect">
+            <a:avLst/>
+          </a:prstGeom>
+        </p:spPr>
+      </p:pic>
     </p:spTree>
   </p:cSld>
   <p:clrMapOvr>
@@ -10918,7 +11334,7 @@
                 <a:ea typeface="Calibri" pitchFamily="34" charset="-122"/>
                 <a:cs typeface="Calibri" pitchFamily="34" charset="-120"/>
               </a:rPr>
-              <a:t>Master in Business Analytics and Big Data</a:t>
+              <a:t>Master in Business Analytics and Data Science</a:t>
             </a:r>
             <a:endParaRPr lang="en-US" sz="900" dirty="0"/>
           </a:p>
@@ -10957,7 +11373,7 @@
                 <a:ea typeface="Calibri" pitchFamily="34" charset="-122"/>
                 <a:cs typeface="Calibri" pitchFamily="34" charset="-120"/>
               </a:rPr>
-              <a:t>MLOps · MBABD-PT 2026–27 · Session 3 · Juan Ramírez</a:t>
+              <a:t>MLOps · MBDS-PT2026F · Session 3 · Juan Ramírez</a:t>
             </a:r>
             <a:endParaRPr lang="en-US" sz="800" dirty="0"/>
           </a:p>
@@ -11106,6 +11522,10 @@
             <a:prstDash val="solid"/>
           </a:ln>
         </p:spPr>
+        <p:txBody>
+          <a:bodyPr/>
+          <a:p/>
+        </p:txBody>
       </p:sp>
       <p:sp>
         <p:nvSpPr>
@@ -11172,6 +11592,10 @@
             <a:prstDash val="solid"/>
           </a:ln>
         </p:spPr>
+        <p:txBody>
+          <a:bodyPr/>
+          <a:p/>
+        </p:txBody>
       </p:sp>
       <p:sp>
         <p:nvSpPr>
@@ -11238,6 +11662,10 @@
             <a:prstDash val="solid"/>
           </a:ln>
         </p:spPr>
+        <p:txBody>
+          <a:bodyPr/>
+          <a:p/>
+        </p:txBody>
       </p:sp>
       <p:sp>
         <p:nvSpPr>
@@ -11304,6 +11732,10 @@
             <a:prstDash val="solid"/>
           </a:ln>
         </p:spPr>
+        <p:txBody>
+          <a:bodyPr/>
+          <a:p/>
+        </p:txBody>
       </p:sp>
       <p:sp>
         <p:nvSpPr>
@@ -11370,6 +11802,10 @@
             <a:prstDash val="solid"/>
           </a:ln>
         </p:spPr>
+        <p:txBody>
+          <a:bodyPr/>
+          <a:p/>
+        </p:txBody>
       </p:sp>
       <p:sp>
         <p:nvSpPr>
@@ -11436,6 +11872,10 @@
             <a:prstDash val="solid"/>
           </a:ln>
         </p:spPr>
+        <p:txBody>
+          <a:bodyPr/>
+          <a:p/>
+        </p:txBody>
       </p:sp>
       <p:sp>
         <p:nvSpPr>
@@ -11502,6 +11942,10 @@
             <a:prstDash val="solid"/>
           </a:ln>
         </p:spPr>
+        <p:txBody>
+          <a:bodyPr/>
+          <a:p/>
+        </p:txBody>
       </p:sp>
       <p:sp>
         <p:nvSpPr>
@@ -11568,6 +12012,10 @@
             <a:prstDash val="solid"/>
           </a:ln>
         </p:spPr>
+        <p:txBody>
+          <a:bodyPr/>
+          <a:p/>
+        </p:txBody>
       </p:sp>
       <p:sp>
         <p:nvSpPr>
@@ -11634,6 +12082,10 @@
             <a:prstDash val="solid"/>
           </a:ln>
         </p:spPr>
+        <p:txBody>
+          <a:bodyPr/>
+          <a:p/>
+        </p:txBody>
       </p:sp>
       <p:sp>
         <p:nvSpPr>
@@ -11713,6 +12165,30 @@
           </a:p>
         </p:txBody>
       </p:sp>
+      <p:pic>
+        <p:nvPicPr>
+          <p:cNvPr id="26" name="IE University logo" descr="IE University, School of Science &amp; Technology"/>
+          <p:cNvPicPr>
+            <a:picLocks noChangeAspect="1"/>
+          </p:cNvPicPr>
+          <p:nvPr/>
+        </p:nvPicPr>
+        <p:blipFill>
+          <a:blip r:embed="rId3"/>
+          <a:stretch>
+            <a:fillRect/>
+          </a:stretch>
+        </p:blipFill>
+        <p:spPr>
+          <a:xfrm>
+            <a:off x="8252653" y="109728"/>
+            <a:ext cx="525587" cy="704395"/>
+          </a:xfrm>
+          <a:prstGeom prst="rect">
+            <a:avLst/>
+          </a:prstGeom>
+        </p:spPr>
+      </p:pic>
     </p:spTree>
   </p:cSld>
   <p:clrMapOvr>
@@ -11778,7 +12254,7 @@
                 <a:ea typeface="Calibri" pitchFamily="34" charset="-122"/>
                 <a:cs typeface="Calibri" pitchFamily="34" charset="-120"/>
               </a:rPr>
-              <a:t>Master in Business Analytics and Big Data</a:t>
+              <a:t>Master in Business Analytics and Data Science</a:t>
             </a:r>
             <a:endParaRPr lang="en-US" sz="900" dirty="0"/>
           </a:p>
@@ -11817,7 +12293,7 @@
                 <a:ea typeface="Calibri" pitchFamily="34" charset="-122"/>
                 <a:cs typeface="Calibri" pitchFamily="34" charset="-120"/>
               </a:rPr>
-              <a:t>MLOps · MBABD-PT 2026–27 · Session 3 · Juan Ramírez</a:t>
+              <a:t>MLOps · MBDS-PT2026F · Session 3 · Juan Ramírez</a:t>
             </a:r>
             <a:endParaRPr lang="en-US" sz="800" dirty="0"/>
           </a:p>
@@ -11927,6 +12403,10 @@
             <a:prstDash val="solid"/>
           </a:ln>
         </p:spPr>
+        <p:txBody>
+          <a:bodyPr/>
+          <a:p/>
+        </p:txBody>
       </p:sp>
       <p:sp>
         <p:nvSpPr>
@@ -12007,6 +12487,10 @@
             <a:tailEnd type="triangle"/>
           </a:ln>
         </p:spPr>
+        <p:txBody>
+          <a:bodyPr/>
+          <a:p/>
+        </p:txBody>
       </p:sp>
       <p:sp>
         <p:nvSpPr>
@@ -12034,6 +12518,10 @@
             <a:prstDash val="solid"/>
           </a:ln>
         </p:spPr>
+        <p:txBody>
+          <a:bodyPr/>
+          <a:p/>
+        </p:txBody>
       </p:sp>
       <p:sp>
         <p:nvSpPr>
@@ -12114,6 +12602,10 @@
             <a:tailEnd type="triangle"/>
           </a:ln>
         </p:spPr>
+        <p:txBody>
+          <a:bodyPr/>
+          <a:p/>
+        </p:txBody>
       </p:sp>
       <p:sp>
         <p:nvSpPr>
@@ -12141,6 +12633,10 @@
             <a:prstDash val="solid"/>
           </a:ln>
         </p:spPr>
+        <p:txBody>
+          <a:bodyPr/>
+          <a:p/>
+        </p:txBody>
       </p:sp>
       <p:sp>
         <p:nvSpPr>
@@ -12222,6 +12718,10 @@
             <a:prstDash val="solid"/>
           </a:ln>
         </p:spPr>
+        <p:txBody>
+          <a:bodyPr/>
+          <a:p/>
+        </p:txBody>
       </p:sp>
       <p:pic>
         <p:nvPicPr>
@@ -12349,6 +12849,10 @@
             <a:prstDash val="solid"/>
           </a:ln>
         </p:spPr>
+        <p:txBody>
+          <a:bodyPr/>
+          <a:p/>
+        </p:txBody>
       </p:sp>
       <p:pic>
         <p:nvPicPr>
@@ -12476,6 +12980,10 @@
             <a:prstDash val="solid"/>
           </a:ln>
         </p:spPr>
+        <p:txBody>
+          <a:bodyPr/>
+          <a:p/>
+        </p:txBody>
       </p:sp>
       <p:pic>
         <p:nvPicPr>
@@ -12605,6 +13113,10 @@
             <a:prstDash val="solid"/>
           </a:ln>
         </p:spPr>
+        <p:txBody>
+          <a:bodyPr/>
+          <a:p/>
+        </p:txBody>
       </p:sp>
       <p:pic>
         <p:nvPicPr>
@@ -12708,6 +13220,30 @@
           </a:p>
         </p:txBody>
       </p:sp>
+      <p:pic>
+        <p:nvPicPr>
+          <p:cNvPr id="31" name="IE University logo" descr="IE University, School of Science &amp; Technology"/>
+          <p:cNvPicPr>
+            <a:picLocks noChangeAspect="1"/>
+          </p:cNvPicPr>
+          <p:nvPr/>
+        </p:nvPicPr>
+        <p:blipFill>
+          <a:blip r:embed="rId7"/>
+          <a:stretch>
+            <a:fillRect/>
+          </a:stretch>
+        </p:blipFill>
+        <p:spPr>
+          <a:xfrm>
+            <a:off x="8013607" y="92634"/>
+            <a:ext cx="764633" cy="262789"/>
+          </a:xfrm>
+          <a:prstGeom prst="rect">
+            <a:avLst/>
+          </a:prstGeom>
+        </p:spPr>
+      </p:pic>
     </p:spTree>
   </p:cSld>
   <p:clrMapOvr>
@@ -12773,7 +13309,7 @@
                 <a:ea typeface="Calibri" pitchFamily="34" charset="-122"/>
                 <a:cs typeface="Calibri" pitchFamily="34" charset="-120"/>
               </a:rPr>
-              <a:t>Master in Business Analytics and Big Data</a:t>
+              <a:t>Master in Business Analytics and Data Science</a:t>
             </a:r>
             <a:endParaRPr lang="en-US" sz="900" dirty="0"/>
           </a:p>
@@ -12812,7 +13348,7 @@
                 <a:ea typeface="Calibri" pitchFamily="34" charset="-122"/>
                 <a:cs typeface="Calibri" pitchFamily="34" charset="-120"/>
               </a:rPr>
-              <a:t>MLOps · MBABD-PT 2026–27 · Session 3 · Juan Ramírez</a:t>
+              <a:t>MLOps · MBDS-PT2026F · Session 3 · Juan Ramírez</a:t>
             </a:r>
             <a:endParaRPr lang="en-US" sz="800" dirty="0"/>
           </a:p>
@@ -12922,6 +13458,10 @@
             <a:prstDash val="solid"/>
           </a:ln>
         </p:spPr>
+        <p:txBody>
+          <a:bodyPr/>
+          <a:p/>
+        </p:txBody>
       </p:sp>
       <p:sp>
         <p:nvSpPr>
@@ -13109,6 +13649,10 @@
             <a:tailEnd type="triangle"/>
           </a:ln>
         </p:spPr>
+        <p:txBody>
+          <a:bodyPr/>
+          <a:p/>
+        </p:txBody>
       </p:sp>
       <p:sp>
         <p:nvSpPr>
@@ -13134,6 +13678,10 @@
             <a:prstDash val="solid"/>
           </a:ln>
         </p:spPr>
+        <p:txBody>
+          <a:bodyPr/>
+          <a:p/>
+        </p:txBody>
       </p:sp>
       <p:sp>
         <p:nvSpPr>
@@ -13200,6 +13748,10 @@
             <a:prstDash val="solid"/>
           </a:ln>
         </p:spPr>
+        <p:txBody>
+          <a:bodyPr/>
+          <a:p/>
+        </p:txBody>
       </p:sp>
       <p:sp>
         <p:nvSpPr>
@@ -13387,6 +13939,10 @@
             <a:tailEnd type="triangle"/>
           </a:ln>
         </p:spPr>
+        <p:txBody>
+          <a:bodyPr/>
+          <a:p/>
+        </p:txBody>
       </p:sp>
       <p:sp>
         <p:nvSpPr>
@@ -13412,6 +13968,10 @@
             <a:prstDash val="solid"/>
           </a:ln>
         </p:spPr>
+        <p:txBody>
+          <a:bodyPr/>
+          <a:p/>
+        </p:txBody>
       </p:sp>
       <p:sp>
         <p:nvSpPr>
@@ -13478,6 +14038,10 @@
             <a:prstDash val="solid"/>
           </a:ln>
         </p:spPr>
+        <p:txBody>
+          <a:bodyPr/>
+          <a:p/>
+        </p:txBody>
       </p:sp>
       <p:sp>
         <p:nvSpPr>
@@ -13668,6 +14232,10 @@
             <a:prstDash val="solid"/>
           </a:ln>
         </p:spPr>
+        <p:txBody>
+          <a:bodyPr/>
+          <a:p/>
+        </p:txBody>
       </p:sp>
       <p:sp>
         <p:nvSpPr>
@@ -13773,6 +14341,10 @@
             <a:prstDash val="solid"/>
           </a:ln>
         </p:spPr>
+        <p:txBody>
+          <a:bodyPr/>
+          <a:p/>
+        </p:txBody>
       </p:sp>
       <p:sp>
         <p:nvSpPr>
@@ -13852,6 +14424,30 @@
           </a:p>
         </p:txBody>
       </p:sp>
+      <p:pic>
+        <p:nvPicPr>
+          <p:cNvPr id="31" name="IE University logo" descr="IE University, School of Science &amp; Technology"/>
+          <p:cNvPicPr>
+            <a:picLocks noChangeAspect="1"/>
+          </p:cNvPicPr>
+          <p:nvPr/>
+        </p:nvPicPr>
+        <p:blipFill>
+          <a:blip r:embed="rId3"/>
+          <a:stretch>
+            <a:fillRect/>
+          </a:stretch>
+        </p:blipFill>
+        <p:spPr>
+          <a:xfrm>
+            <a:off x="8013607" y="92634"/>
+            <a:ext cx="764633" cy="262789"/>
+          </a:xfrm>
+          <a:prstGeom prst="rect">
+            <a:avLst/>
+          </a:prstGeom>
+        </p:spPr>
+      </p:pic>
     </p:spTree>
   </p:cSld>
   <p:clrMapOvr>
@@ -13917,7 +14513,7 @@
                 <a:ea typeface="Calibri" pitchFamily="34" charset="-122"/>
                 <a:cs typeface="Calibri" pitchFamily="34" charset="-120"/>
               </a:rPr>
-              <a:t>Master in Business Analytics and Big Data</a:t>
+              <a:t>Master in Business Analytics and Data Science</a:t>
             </a:r>
             <a:endParaRPr lang="en-US" sz="900" dirty="0"/>
           </a:p>
@@ -13956,7 +14552,7 @@
                 <a:ea typeface="Calibri" pitchFamily="34" charset="-122"/>
                 <a:cs typeface="Calibri" pitchFamily="34" charset="-120"/>
               </a:rPr>
-              <a:t>MLOps · MBABD-PT 2026–27 · Session 3 · Juan Ramírez</a:t>
+              <a:t>MLOps · MBDS-PT2026F · Session 3 · Juan Ramírez</a:t>
             </a:r>
             <a:endParaRPr lang="en-US" sz="800" dirty="0"/>
           </a:p>
@@ -14105,6 +14701,10 @@
             <a:prstDash val="solid"/>
           </a:ln>
         </p:spPr>
+        <p:txBody>
+          <a:bodyPr/>
+          <a:p/>
+        </p:txBody>
       </p:sp>
       <p:sp>
         <p:nvSpPr>
@@ -14293,6 +14893,10 @@
             <a:prstDash val="solid"/>
           </a:ln>
         </p:spPr>
+        <p:txBody>
+          <a:bodyPr/>
+          <a:p/>
+        </p:txBody>
       </p:sp>
       <p:pic>
         <p:nvPicPr>
@@ -14420,6 +15024,10 @@
             <a:prstDash val="solid"/>
           </a:ln>
         </p:spPr>
+        <p:txBody>
+          <a:bodyPr/>
+          <a:p/>
+        </p:txBody>
       </p:sp>
       <p:pic>
         <p:nvPicPr>
@@ -15879,6 +16487,30 @@
           </a:graphicData>
         </a:graphic>
       </p:graphicFrame>
+      <p:pic>
+        <p:nvPicPr>
+          <p:cNvPr id="20" name="IE University logo" descr="IE University, School of Science &amp; Technology"/>
+          <p:cNvPicPr>
+            <a:picLocks noChangeAspect="1"/>
+          </p:cNvPicPr>
+          <p:nvPr/>
+        </p:nvPicPr>
+        <p:blipFill>
+          <a:blip r:embed="rId5"/>
+          <a:stretch>
+            <a:fillRect/>
+          </a:stretch>
+        </p:blipFill>
+        <p:spPr>
+          <a:xfrm>
+            <a:off x="8013607" y="92634"/>
+            <a:ext cx="764633" cy="262789"/>
+          </a:xfrm>
+          <a:prstGeom prst="rect">
+            <a:avLst/>
+          </a:prstGeom>
+        </p:spPr>
+      </p:pic>
     </p:spTree>
   </p:cSld>
   <p:clrMapOvr>
@@ -15944,7 +16576,7 @@
                 <a:ea typeface="Calibri" pitchFamily="34" charset="-122"/>
                 <a:cs typeface="Calibri" pitchFamily="34" charset="-120"/>
               </a:rPr>
-              <a:t>Master in Business Analytics and Big Data</a:t>
+              <a:t>Master in Business Analytics and Data Science</a:t>
             </a:r>
             <a:endParaRPr lang="en-US" sz="900" dirty="0"/>
           </a:p>
@@ -15983,7 +16615,7 @@
                 <a:ea typeface="Calibri" pitchFamily="34" charset="-122"/>
                 <a:cs typeface="Calibri" pitchFamily="34" charset="-120"/>
               </a:rPr>
-              <a:t>MLOps · MBABD-PT 2026–27 · Session 3 · Juan Ramírez</a:t>
+              <a:t>MLOps · MBDS-PT2026F · Session 3 · Juan Ramírez</a:t>
             </a:r>
             <a:endParaRPr lang="en-US" sz="800" dirty="0"/>
           </a:p>
@@ -16091,6 +16723,10 @@
             <a:prstDash val="solid"/>
           </a:ln>
         </p:spPr>
+        <p:txBody>
+          <a:bodyPr/>
+          <a:p/>
+        </p:txBody>
       </p:sp>
       <p:pic>
         <p:nvPicPr>
@@ -16218,6 +16854,10 @@
             <a:prstDash val="solid"/>
           </a:ln>
         </p:spPr>
+        <p:txBody>
+          <a:bodyPr/>
+          <a:p/>
+        </p:txBody>
       </p:sp>
       <p:pic>
         <p:nvPicPr>
@@ -16345,6 +16985,10 @@
             <a:prstDash val="solid"/>
           </a:ln>
         </p:spPr>
+        <p:txBody>
+          <a:bodyPr/>
+          <a:p/>
+        </p:txBody>
       </p:sp>
       <p:pic>
         <p:nvPicPr>
@@ -16472,6 +17116,10 @@
             <a:prstDash val="solid"/>
           </a:ln>
         </p:spPr>
+        <p:txBody>
+          <a:bodyPr/>
+          <a:p/>
+        </p:txBody>
       </p:sp>
       <p:pic>
         <p:nvPicPr>
@@ -16599,6 +17247,10 @@
             <a:prstDash val="solid"/>
           </a:ln>
         </p:spPr>
+        <p:txBody>
+          <a:bodyPr/>
+          <a:p/>
+        </p:txBody>
       </p:sp>
       <p:pic>
         <p:nvPicPr>
@@ -16726,6 +17378,10 @@
             <a:prstDash val="solid"/>
           </a:ln>
         </p:spPr>
+        <p:txBody>
+          <a:bodyPr/>
+          <a:p/>
+        </p:txBody>
       </p:sp>
       <p:pic>
         <p:nvPicPr>
@@ -16855,6 +17511,10 @@
             <a:prstDash val="solid"/>
           </a:ln>
         </p:spPr>
+        <p:txBody>
+          <a:bodyPr/>
+          <a:p/>
+        </p:txBody>
       </p:sp>
       <p:pic>
         <p:nvPicPr>
@@ -16919,6 +17579,30 @@
           </a:p>
         </p:txBody>
       </p:sp>
+      <p:pic>
+        <p:nvPicPr>
+          <p:cNvPr id="34" name="IE University logo" descr="IE University, School of Science &amp; Technology"/>
+          <p:cNvPicPr>
+            <a:picLocks noChangeAspect="1"/>
+          </p:cNvPicPr>
+          <p:nvPr/>
+        </p:nvPicPr>
+        <p:blipFill>
+          <a:blip r:embed="rId10"/>
+          <a:stretch>
+            <a:fillRect/>
+          </a:stretch>
+        </p:blipFill>
+        <p:spPr>
+          <a:xfrm>
+            <a:off x="8013607" y="92634"/>
+            <a:ext cx="764633" cy="262789"/>
+          </a:xfrm>
+          <a:prstGeom prst="rect">
+            <a:avLst/>
+          </a:prstGeom>
+        </p:spPr>
+      </p:pic>
     </p:spTree>
   </p:cSld>
   <p:clrMapOvr>
@@ -16984,7 +17668,7 @@
                 <a:ea typeface="Calibri" pitchFamily="34" charset="-122"/>
                 <a:cs typeface="Calibri" pitchFamily="34" charset="-120"/>
               </a:rPr>
-              <a:t>Master in Business Analytics and Big Data</a:t>
+              <a:t>Master in Business Analytics and Data Science</a:t>
             </a:r>
             <a:endParaRPr lang="en-US" sz="900" dirty="0"/>
           </a:p>
@@ -17023,7 +17707,7 @@
                 <a:ea typeface="Calibri" pitchFamily="34" charset="-122"/>
                 <a:cs typeface="Calibri" pitchFamily="34" charset="-120"/>
               </a:rPr>
-              <a:t>MLOps · MBABD-PT 2026–27 · Session 3 · Juan Ramírez</a:t>
+              <a:t>MLOps · MBDS-PT2026F · Session 3 · Juan Ramírez</a:t>
             </a:r>
             <a:endParaRPr lang="en-US" sz="800" dirty="0"/>
           </a:p>
@@ -17133,6 +17817,10 @@
             <a:prstDash val="solid"/>
           </a:ln>
         </p:spPr>
+        <p:txBody>
+          <a:bodyPr/>
+          <a:p/>
+        </p:txBody>
       </p:sp>
       <p:sp>
         <p:nvSpPr>
@@ -17213,6 +17901,10 @@
             <a:tailEnd type="triangle"/>
           </a:ln>
         </p:spPr>
+        <p:txBody>
+          <a:bodyPr/>
+          <a:p/>
+        </p:txBody>
       </p:sp>
       <p:sp>
         <p:nvSpPr>
@@ -17240,6 +17932,10 @@
             <a:prstDash val="solid"/>
           </a:ln>
         </p:spPr>
+        <p:txBody>
+          <a:bodyPr/>
+          <a:p/>
+        </p:txBody>
       </p:sp>
       <p:sp>
         <p:nvSpPr>
@@ -17320,6 +18016,10 @@
             <a:tailEnd type="triangle"/>
           </a:ln>
         </p:spPr>
+        <p:txBody>
+          <a:bodyPr/>
+          <a:p/>
+        </p:txBody>
       </p:sp>
       <p:sp>
         <p:nvSpPr>
@@ -17347,6 +18047,10 @@
             <a:prstDash val="solid"/>
           </a:ln>
         </p:spPr>
+        <p:txBody>
+          <a:bodyPr/>
+          <a:p/>
+        </p:txBody>
       </p:sp>
       <p:sp>
         <p:nvSpPr>
@@ -17427,6 +18131,10 @@
             <a:tailEnd type="triangle"/>
           </a:ln>
         </p:spPr>
+        <p:txBody>
+          <a:bodyPr/>
+          <a:p/>
+        </p:txBody>
       </p:sp>
       <p:sp>
         <p:nvSpPr>
@@ -17454,6 +18162,10 @@
             <a:prstDash val="solid"/>
           </a:ln>
         </p:spPr>
+        <p:txBody>
+          <a:bodyPr/>
+          <a:p/>
+        </p:txBody>
       </p:sp>
       <p:sp>
         <p:nvSpPr>
@@ -17534,6 +18246,10 @@
             <a:tailEnd type="triangle"/>
           </a:ln>
         </p:spPr>
+        <p:txBody>
+          <a:bodyPr/>
+          <a:p/>
+        </p:txBody>
       </p:sp>
       <p:sp>
         <p:nvSpPr>
@@ -17561,6 +18277,10 @@
             <a:prstDash val="solid"/>
           </a:ln>
         </p:spPr>
+        <p:txBody>
+          <a:bodyPr/>
+          <a:p/>
+        </p:txBody>
       </p:sp>
       <p:sp>
         <p:nvSpPr>
@@ -17683,6 +18403,10 @@
             <a:prstDash val="solid"/>
           </a:ln>
         </p:spPr>
+        <p:txBody>
+          <a:bodyPr/>
+          <a:p/>
+        </p:txBody>
       </p:sp>
       <p:sp>
         <p:nvSpPr>
@@ -17708,6 +18432,10 @@
             <a:prstDash val="solid"/>
           </a:ln>
         </p:spPr>
+        <p:txBody>
+          <a:bodyPr/>
+          <a:p/>
+        </p:txBody>
       </p:sp>
       <p:pic>
         <p:nvPicPr>
@@ -17862,6 +18590,10 @@
             <a:prstDash val="solid"/>
           </a:ln>
         </p:spPr>
+        <p:txBody>
+          <a:bodyPr/>
+          <a:p/>
+        </p:txBody>
       </p:sp>
       <p:sp>
         <p:nvSpPr>
@@ -17887,6 +18619,10 @@
             <a:prstDash val="solid"/>
           </a:ln>
         </p:spPr>
+        <p:txBody>
+          <a:bodyPr/>
+          <a:p/>
+        </p:txBody>
       </p:sp>
       <p:pic>
         <p:nvPicPr>
@@ -18041,6 +18777,10 @@
             <a:prstDash val="solid"/>
           </a:ln>
         </p:spPr>
+        <p:txBody>
+          <a:bodyPr/>
+          <a:p/>
+        </p:txBody>
       </p:sp>
       <p:pic>
         <p:nvPicPr>
@@ -18105,6 +18845,30 @@
           </a:p>
         </p:txBody>
       </p:sp>
+      <p:pic>
+        <p:nvPicPr>
+          <p:cNvPr id="35" name="IE University logo" descr="IE University, School of Science &amp; Technology"/>
+          <p:cNvPicPr>
+            <a:picLocks noChangeAspect="1"/>
+          </p:cNvPicPr>
+          <p:nvPr/>
+        </p:nvPicPr>
+        <p:blipFill>
+          <a:blip r:embed="rId6"/>
+          <a:stretch>
+            <a:fillRect/>
+          </a:stretch>
+        </p:blipFill>
+        <p:spPr>
+          <a:xfrm>
+            <a:off x="8013607" y="92634"/>
+            <a:ext cx="764633" cy="262789"/>
+          </a:xfrm>
+          <a:prstGeom prst="rect">
+            <a:avLst/>
+          </a:prstGeom>
+        </p:spPr>
+      </p:pic>
     </p:spTree>
   </p:cSld>
   <p:clrMapOvr>
@@ -18170,7 +18934,7 @@
                 <a:ea typeface="Calibri" pitchFamily="34" charset="-122"/>
                 <a:cs typeface="Calibri" pitchFamily="34" charset="-120"/>
               </a:rPr>
-              <a:t>Master in Business Analytics and Big Data</a:t>
+              <a:t>Master in Business Analytics and Data Science</a:t>
             </a:r>
             <a:endParaRPr lang="en-US" sz="900" dirty="0"/>
           </a:p>
@@ -18209,7 +18973,7 @@
                 <a:ea typeface="Calibri" pitchFamily="34" charset="-122"/>
                 <a:cs typeface="Calibri" pitchFamily="34" charset="-120"/>
               </a:rPr>
-              <a:t>MLOps · MBABD-PT 2026–27 · Session 3 · Juan Ramírez</a:t>
+              <a:t>MLOps · MBDS-PT2026F · Session 3 · Juan Ramírez</a:t>
             </a:r>
             <a:endParaRPr lang="en-US" sz="800" dirty="0"/>
           </a:p>
@@ -18332,6 +19096,30 @@
           </a:p>
         </p:txBody>
       </p:sp>
+      <p:pic>
+        <p:nvPicPr>
+          <p:cNvPr id="7" name="IE University logo" descr="IE University, School of Science &amp; Technology"/>
+          <p:cNvPicPr>
+            <a:picLocks noChangeAspect="1"/>
+          </p:cNvPicPr>
+          <p:nvPr/>
+        </p:nvPicPr>
+        <p:blipFill>
+          <a:blip r:embed="rId3"/>
+          <a:stretch>
+            <a:fillRect/>
+          </a:stretch>
+        </p:blipFill>
+        <p:spPr>
+          <a:xfrm>
+            <a:off x="8252653" y="109728"/>
+            <a:ext cx="525587" cy="704395"/>
+          </a:xfrm>
+          <a:prstGeom prst="rect">
+            <a:avLst/>
+          </a:prstGeom>
+        </p:spPr>
+      </p:pic>
     </p:spTree>
   </p:cSld>
   <p:clrMapOvr>
@@ -18397,7 +19185,7 @@
                 <a:ea typeface="Calibri" pitchFamily="34" charset="-122"/>
                 <a:cs typeface="Calibri" pitchFamily="34" charset="-120"/>
               </a:rPr>
-              <a:t>Master in Business Analytics and Big Data</a:t>
+              <a:t>Master in Business Analytics and Data Science</a:t>
             </a:r>
             <a:endParaRPr lang="en-US" sz="900" dirty="0"/>
           </a:p>
@@ -18436,7 +19224,7 @@
                 <a:ea typeface="Calibri" pitchFamily="34" charset="-122"/>
                 <a:cs typeface="Calibri" pitchFamily="34" charset="-120"/>
               </a:rPr>
-              <a:t>MLOps · MBABD-PT 2026–27 · Session 3 · Juan Ramírez</a:t>
+              <a:t>MLOps · MBDS-PT2026F · Session 3 · Juan Ramírez</a:t>
             </a:r>
             <a:endParaRPr lang="en-US" sz="800" dirty="0"/>
           </a:p>
@@ -18585,6 +19373,10 @@
             <a:prstDash val="solid"/>
           </a:ln>
         </p:spPr>
+        <p:txBody>
+          <a:bodyPr/>
+          <a:p/>
+        </p:txBody>
       </p:sp>
       <p:sp>
         <p:nvSpPr>
@@ -18651,6 +19443,10 @@
             <a:prstDash val="solid"/>
           </a:ln>
         </p:spPr>
+        <p:txBody>
+          <a:bodyPr/>
+          <a:p/>
+        </p:txBody>
       </p:sp>
       <p:sp>
         <p:nvSpPr>
@@ -18717,6 +19513,10 @@
             <a:prstDash val="solid"/>
           </a:ln>
         </p:spPr>
+        <p:txBody>
+          <a:bodyPr/>
+          <a:p/>
+        </p:txBody>
       </p:sp>
       <p:sp>
         <p:nvSpPr>
@@ -18783,6 +19583,10 @@
             <a:prstDash val="solid"/>
           </a:ln>
         </p:spPr>
+        <p:txBody>
+          <a:bodyPr/>
+          <a:p/>
+        </p:txBody>
       </p:sp>
       <p:sp>
         <p:nvSpPr>
@@ -18849,6 +19653,10 @@
             <a:prstDash val="solid"/>
           </a:ln>
         </p:spPr>
+        <p:txBody>
+          <a:bodyPr/>
+          <a:p/>
+        </p:txBody>
       </p:sp>
       <p:sp>
         <p:nvSpPr>
@@ -18915,6 +19723,10 @@
             <a:prstDash val="solid"/>
           </a:ln>
         </p:spPr>
+        <p:txBody>
+          <a:bodyPr/>
+          <a:p/>
+        </p:txBody>
       </p:sp>
       <p:sp>
         <p:nvSpPr>
@@ -18981,6 +19793,10 @@
             <a:prstDash val="solid"/>
           </a:ln>
         </p:spPr>
+        <p:txBody>
+          <a:bodyPr/>
+          <a:p/>
+        </p:txBody>
       </p:sp>
       <p:sp>
         <p:nvSpPr>
@@ -19047,6 +19863,10 @@
             <a:prstDash val="solid"/>
           </a:ln>
         </p:spPr>
+        <p:txBody>
+          <a:bodyPr/>
+          <a:p/>
+        </p:txBody>
       </p:sp>
       <p:sp>
         <p:nvSpPr>
@@ -19113,6 +19933,10 @@
             <a:prstDash val="solid"/>
           </a:ln>
         </p:spPr>
+        <p:txBody>
+          <a:bodyPr/>
+          <a:p/>
+        </p:txBody>
       </p:sp>
       <p:sp>
         <p:nvSpPr>
@@ -19192,6 +20016,30 @@
           </a:p>
         </p:txBody>
       </p:sp>
+      <p:pic>
+        <p:nvPicPr>
+          <p:cNvPr id="26" name="IE University logo" descr="IE University, School of Science &amp; Technology"/>
+          <p:cNvPicPr>
+            <a:picLocks noChangeAspect="1"/>
+          </p:cNvPicPr>
+          <p:nvPr/>
+        </p:nvPicPr>
+        <p:blipFill>
+          <a:blip r:embed="rId3"/>
+          <a:stretch>
+            <a:fillRect/>
+          </a:stretch>
+        </p:blipFill>
+        <p:spPr>
+          <a:xfrm>
+            <a:off x="8252653" y="109728"/>
+            <a:ext cx="525587" cy="704395"/>
+          </a:xfrm>
+          <a:prstGeom prst="rect">
+            <a:avLst/>
+          </a:prstGeom>
+        </p:spPr>
+      </p:pic>
     </p:spTree>
   </p:cSld>
   <p:clrMapOvr>
@@ -19257,7 +20105,7 @@
                 <a:ea typeface="Calibri" pitchFamily="34" charset="-122"/>
                 <a:cs typeface="Calibri" pitchFamily="34" charset="-120"/>
               </a:rPr>
-              <a:t>Master in Business Analytics and Big Data</a:t>
+              <a:t>Master in Business Analytics and Data Science</a:t>
             </a:r>
             <a:endParaRPr lang="en-US" sz="900" dirty="0"/>
           </a:p>
@@ -19296,7 +20144,7 @@
                 <a:ea typeface="Calibri" pitchFamily="34" charset="-122"/>
                 <a:cs typeface="Calibri" pitchFamily="34" charset="-120"/>
               </a:rPr>
-              <a:t>MLOps · MBABD-PT 2026–27 · Session 3 · Juan Ramírez</a:t>
+              <a:t>MLOps · MBDS-PT2026F · Session 3 · Juan Ramírez</a:t>
             </a:r>
             <a:endParaRPr lang="en-US" sz="800" dirty="0"/>
           </a:p>
@@ -19406,6 +20254,10 @@
             <a:prstDash val="solid"/>
           </a:ln>
         </p:spPr>
+        <p:txBody>
+          <a:bodyPr/>
+          <a:p/>
+        </p:txBody>
       </p:sp>
       <p:sp>
         <p:nvSpPr>
@@ -19431,6 +20283,10 @@
             <a:prstDash val="solid"/>
           </a:ln>
         </p:spPr>
+        <p:txBody>
+          <a:bodyPr/>
+          <a:p/>
+        </p:txBody>
       </p:sp>
       <p:pic>
         <p:nvPicPr>
@@ -19690,6 +20546,10 @@
             <a:prstDash val="solid"/>
           </a:ln>
         </p:spPr>
+        <p:txBody>
+          <a:bodyPr/>
+          <a:p/>
+        </p:txBody>
       </p:sp>
       <p:sp>
         <p:nvSpPr>
@@ -19715,6 +20575,10 @@
             <a:prstDash val="solid"/>
           </a:ln>
         </p:spPr>
+        <p:txBody>
+          <a:bodyPr/>
+          <a:p/>
+        </p:txBody>
       </p:sp>
       <p:pic>
         <p:nvPicPr>
@@ -19890,6 +20754,10 @@
             <a:prstDash val="solid"/>
           </a:ln>
         </p:spPr>
+        <p:txBody>
+          <a:bodyPr/>
+          <a:p/>
+        </p:txBody>
       </p:sp>
       <p:sp>
         <p:nvSpPr>
@@ -19915,6 +20783,10 @@
             <a:prstDash val="solid"/>
           </a:ln>
         </p:spPr>
+        <p:txBody>
+          <a:bodyPr/>
+          <a:p/>
+        </p:txBody>
       </p:sp>
       <p:pic>
         <p:nvPicPr>
@@ -20082,6 +20954,30 @@
           </a:p>
         </p:txBody>
       </p:sp>
+      <p:pic>
+        <p:nvPicPr>
+          <p:cNvPr id="23" name="IE University logo" descr="IE University, School of Science &amp; Technology"/>
+          <p:cNvPicPr>
+            <a:picLocks noChangeAspect="1"/>
+          </p:cNvPicPr>
+          <p:nvPr/>
+        </p:nvPicPr>
+        <p:blipFill>
+          <a:blip r:embed="rId6"/>
+          <a:stretch>
+            <a:fillRect/>
+          </a:stretch>
+        </p:blipFill>
+        <p:spPr>
+          <a:xfrm>
+            <a:off x="8013607" y="92634"/>
+            <a:ext cx="764633" cy="262789"/>
+          </a:xfrm>
+          <a:prstGeom prst="rect">
+            <a:avLst/>
+          </a:prstGeom>
+        </p:spPr>
+      </p:pic>
     </p:spTree>
   </p:cSld>
   <p:clrMapOvr>
@@ -20147,7 +21043,7 @@
                 <a:ea typeface="Calibri" pitchFamily="34" charset="-122"/>
                 <a:cs typeface="Calibri" pitchFamily="34" charset="-120"/>
               </a:rPr>
-              <a:t>Master in Business Analytics and Big Data</a:t>
+              <a:t>Master in Business Analytics and Data Science</a:t>
             </a:r>
             <a:endParaRPr lang="en-US" sz="900" dirty="0"/>
           </a:p>
@@ -20186,7 +21082,7 @@
                 <a:ea typeface="Calibri" pitchFamily="34" charset="-122"/>
                 <a:cs typeface="Calibri" pitchFamily="34" charset="-120"/>
               </a:rPr>
-              <a:t>MLOps · MBABD-PT 2026–27 · Session 3 · Juan Ramírez</a:t>
+              <a:t>MLOps · MBDS-PT2026F · Session 3 · Juan Ramírez</a:t>
             </a:r>
             <a:endParaRPr lang="en-US" sz="800" dirty="0"/>
           </a:p>
@@ -20296,6 +21192,10 @@
             <a:prstDash val="solid"/>
           </a:ln>
         </p:spPr>
+        <p:txBody>
+          <a:bodyPr/>
+          <a:p/>
+        </p:txBody>
       </p:sp>
       <p:sp>
         <p:nvSpPr>
@@ -20321,6 +21221,10 @@
             <a:prstDash val="solid"/>
           </a:ln>
         </p:spPr>
+        <p:txBody>
+          <a:bodyPr/>
+          <a:p/>
+        </p:txBody>
       </p:sp>
       <p:pic>
         <p:nvPicPr>
@@ -20503,6 +21407,10 @@
             <a:prstDash val="solid"/>
           </a:ln>
         </p:spPr>
+        <p:txBody>
+          <a:bodyPr/>
+          <a:p/>
+        </p:txBody>
       </p:sp>
       <p:sp>
         <p:nvSpPr>
@@ -20528,6 +21436,10 @@
             <a:prstDash val="solid"/>
           </a:ln>
         </p:spPr>
+        <p:txBody>
+          <a:bodyPr/>
+          <a:p/>
+        </p:txBody>
       </p:sp>
       <p:pic>
         <p:nvPicPr>
@@ -20710,6 +21622,10 @@
             <a:prstDash val="solid"/>
           </a:ln>
         </p:spPr>
+        <p:txBody>
+          <a:bodyPr/>
+          <a:p/>
+        </p:txBody>
       </p:sp>
       <p:sp>
         <p:nvSpPr>
@@ -20735,6 +21651,10 @@
             <a:prstDash val="solid"/>
           </a:ln>
         </p:spPr>
+        <p:txBody>
+          <a:bodyPr/>
+          <a:p/>
+        </p:txBody>
       </p:sp>
       <p:pic>
         <p:nvPicPr>
@@ -20917,6 +21837,10 @@
             <a:prstDash val="solid"/>
           </a:ln>
         </p:spPr>
+        <p:txBody>
+          <a:bodyPr/>
+          <a:p/>
+        </p:txBody>
       </p:sp>
       <p:sp>
         <p:nvSpPr>
@@ -20942,6 +21866,10 @@
             <a:prstDash val="solid"/>
           </a:ln>
         </p:spPr>
+        <p:txBody>
+          <a:bodyPr/>
+          <a:p/>
+        </p:txBody>
       </p:sp>
       <p:pic>
         <p:nvPicPr>
@@ -21124,6 +22052,10 @@
             <a:prstDash val="solid"/>
           </a:ln>
         </p:spPr>
+        <p:txBody>
+          <a:bodyPr/>
+          <a:p/>
+        </p:txBody>
       </p:sp>
       <p:pic>
         <p:nvPicPr>
@@ -21188,6 +22120,30 @@
           </a:p>
         </p:txBody>
       </p:sp>
+      <p:pic>
+        <p:nvPicPr>
+          <p:cNvPr id="34" name="IE University logo" descr="IE University, School of Science &amp; Technology"/>
+          <p:cNvPicPr>
+            <a:picLocks noChangeAspect="1"/>
+          </p:cNvPicPr>
+          <p:nvPr/>
+        </p:nvPicPr>
+        <p:blipFill>
+          <a:blip r:embed="rId8"/>
+          <a:stretch>
+            <a:fillRect/>
+          </a:stretch>
+        </p:blipFill>
+        <p:spPr>
+          <a:xfrm>
+            <a:off x="8013607" y="92634"/>
+            <a:ext cx="764633" cy="262789"/>
+          </a:xfrm>
+          <a:prstGeom prst="rect">
+            <a:avLst/>
+          </a:prstGeom>
+        </p:spPr>
+      </p:pic>
     </p:spTree>
   </p:cSld>
   <p:clrMapOvr>
@@ -21253,7 +22209,7 @@
                 <a:ea typeface="Calibri" pitchFamily="34" charset="-122"/>
                 <a:cs typeface="Calibri" pitchFamily="34" charset="-120"/>
               </a:rPr>
-              <a:t>Master in Business Analytics and Big Data</a:t>
+              <a:t>Master in Business Analytics and Data Science</a:t>
             </a:r>
             <a:endParaRPr lang="en-US" sz="900" dirty="0"/>
           </a:p>
@@ -21292,7 +22248,7 @@
                 <a:ea typeface="Calibri" pitchFamily="34" charset="-122"/>
                 <a:cs typeface="Calibri" pitchFamily="34" charset="-120"/>
               </a:rPr>
-              <a:t>MLOps · MBABD-PT 2026–27 · Session 3 · Juan Ramírez</a:t>
+              <a:t>MLOps · MBDS-PT2026F · Session 3 · Juan Ramírez</a:t>
             </a:r>
             <a:endParaRPr lang="en-US" sz="800" dirty="0"/>
           </a:p>
@@ -21402,6 +22358,10 @@
             <a:prstDash val="solid"/>
           </a:ln>
         </p:spPr>
+        <p:txBody>
+          <a:bodyPr/>
+          <a:p/>
+        </p:txBody>
       </p:sp>
       <p:sp>
         <p:nvSpPr>
@@ -21427,6 +22387,10 @@
             <a:prstDash val="solid"/>
           </a:ln>
         </p:spPr>
+        <p:txBody>
+          <a:bodyPr/>
+          <a:p/>
+        </p:txBody>
       </p:sp>
       <p:pic>
         <p:nvPicPr>
@@ -21644,6 +22608,10 @@
             <a:prstDash val="solid"/>
           </a:ln>
         </p:spPr>
+        <p:txBody>
+          <a:bodyPr/>
+          <a:p/>
+        </p:txBody>
       </p:sp>
       <p:sp>
         <p:nvSpPr>
@@ -21669,6 +22637,10 @@
             <a:prstDash val="solid"/>
           </a:ln>
         </p:spPr>
+        <p:txBody>
+          <a:bodyPr/>
+          <a:p/>
+        </p:txBody>
       </p:sp>
       <p:pic>
         <p:nvPicPr>
@@ -21865,6 +22837,10 @@
             <a:prstDash val="solid"/>
           </a:ln>
         </p:spPr>
+        <p:txBody>
+          <a:bodyPr/>
+          <a:p/>
+        </p:txBody>
       </p:sp>
       <p:sp>
         <p:nvSpPr>
@@ -21890,6 +22866,10 @@
             <a:prstDash val="solid"/>
           </a:ln>
         </p:spPr>
+        <p:txBody>
+          <a:bodyPr/>
+          <a:p/>
+        </p:txBody>
       </p:sp>
       <p:pic>
         <p:nvPicPr>
@@ -22107,6 +23087,10 @@
             <a:prstDash val="solid"/>
           </a:ln>
         </p:spPr>
+        <p:txBody>
+          <a:bodyPr/>
+          <a:p/>
+        </p:txBody>
       </p:sp>
       <p:pic>
         <p:nvPicPr>
@@ -22171,6 +23155,30 @@
           </a:p>
         </p:txBody>
       </p:sp>
+      <p:pic>
+        <p:nvPicPr>
+          <p:cNvPr id="25" name="IE University logo" descr="IE University, School of Science &amp; Technology"/>
+          <p:cNvPicPr>
+            <a:picLocks noChangeAspect="1"/>
+          </p:cNvPicPr>
+          <p:nvPr/>
+        </p:nvPicPr>
+        <p:blipFill>
+          <a:blip r:embed="rId7"/>
+          <a:stretch>
+            <a:fillRect/>
+          </a:stretch>
+        </p:blipFill>
+        <p:spPr>
+          <a:xfrm>
+            <a:off x="8013607" y="92634"/>
+            <a:ext cx="764633" cy="262789"/>
+          </a:xfrm>
+          <a:prstGeom prst="rect">
+            <a:avLst/>
+          </a:prstGeom>
+        </p:spPr>
+      </p:pic>
     </p:spTree>
   </p:cSld>
   <p:clrMapOvr>
@@ -22236,7 +23244,7 @@
                 <a:ea typeface="Calibri" pitchFamily="34" charset="-122"/>
                 <a:cs typeface="Calibri" pitchFamily="34" charset="-120"/>
               </a:rPr>
-              <a:t>Master in Business Analytics and Big Data</a:t>
+              <a:t>Master in Business Analytics and Data Science</a:t>
             </a:r>
             <a:endParaRPr lang="en-US" sz="900" dirty="0"/>
           </a:p>
@@ -22275,7 +23283,7 @@
                 <a:ea typeface="Calibri" pitchFamily="34" charset="-122"/>
                 <a:cs typeface="Calibri" pitchFamily="34" charset="-120"/>
               </a:rPr>
-              <a:t>MLOps · MBABD-PT 2026–27 · Session 3 · Juan Ramírez</a:t>
+              <a:t>MLOps · MBDS-PT2026F · Session 3 · Juan Ramírez</a:t>
             </a:r>
             <a:endParaRPr lang="en-US" sz="800" dirty="0"/>
           </a:p>
@@ -22385,6 +23393,10 @@
             <a:prstDash val="solid"/>
           </a:ln>
         </p:spPr>
+        <p:txBody>
+          <a:bodyPr/>
+          <a:p/>
+        </p:txBody>
       </p:sp>
       <p:sp>
         <p:nvSpPr>
@@ -22410,6 +23422,10 @@
             <a:prstDash val="solid"/>
           </a:ln>
         </p:spPr>
+        <p:txBody>
+          <a:bodyPr/>
+          <a:p/>
+        </p:txBody>
       </p:sp>
       <p:pic>
         <p:nvPicPr>
@@ -22585,6 +23601,10 @@
             <a:prstDash val="solid"/>
           </a:ln>
         </p:spPr>
+        <p:txBody>
+          <a:bodyPr/>
+          <a:p/>
+        </p:txBody>
       </p:sp>
       <p:sp>
         <p:nvSpPr>
@@ -22610,6 +23630,10 @@
             <a:prstDash val="solid"/>
           </a:ln>
         </p:spPr>
+        <p:txBody>
+          <a:bodyPr/>
+          <a:p/>
+        </p:txBody>
       </p:sp>
       <p:pic>
         <p:nvPicPr>
@@ -22806,6 +23830,10 @@
             <a:prstDash val="solid"/>
           </a:ln>
         </p:spPr>
+        <p:txBody>
+          <a:bodyPr/>
+          <a:p/>
+        </p:txBody>
       </p:sp>
       <p:pic>
         <p:nvPicPr>
@@ -22870,6 +23898,30 @@
           </a:p>
         </p:txBody>
       </p:sp>
+      <p:pic>
+        <p:nvPicPr>
+          <p:cNvPr id="20" name="IE University logo" descr="IE University, School of Science &amp; Technology"/>
+          <p:cNvPicPr>
+            <a:picLocks noChangeAspect="1"/>
+          </p:cNvPicPr>
+          <p:nvPr/>
+        </p:nvPicPr>
+        <p:blipFill>
+          <a:blip r:embed="rId6"/>
+          <a:stretch>
+            <a:fillRect/>
+          </a:stretch>
+        </p:blipFill>
+        <p:spPr>
+          <a:xfrm>
+            <a:off x="8013607" y="92634"/>
+            <a:ext cx="764633" cy="262789"/>
+          </a:xfrm>
+          <a:prstGeom prst="rect">
+            <a:avLst/>
+          </a:prstGeom>
+        </p:spPr>
+      </p:pic>
     </p:spTree>
   </p:cSld>
   <p:clrMapOvr>
@@ -22935,7 +23987,7 @@
                 <a:ea typeface="Calibri" pitchFamily="34" charset="-122"/>
                 <a:cs typeface="Calibri" pitchFamily="34" charset="-120"/>
               </a:rPr>
-              <a:t>Master in Business Analytics and Big Data</a:t>
+              <a:t>Master in Business Analytics and Data Science</a:t>
             </a:r>
             <a:endParaRPr lang="en-US" sz="900" dirty="0"/>
           </a:p>
@@ -22974,7 +24026,7 @@
                 <a:ea typeface="Calibri" pitchFamily="34" charset="-122"/>
                 <a:cs typeface="Calibri" pitchFamily="34" charset="-120"/>
               </a:rPr>
-              <a:t>MLOps · MBABD-PT 2026–27 · Session 3 · Juan Ramírez</a:t>
+              <a:t>MLOps · MBDS-PT2026F · Session 3 · Juan Ramírez</a:t>
             </a:r>
             <a:endParaRPr lang="en-US" sz="800" dirty="0"/>
           </a:p>
@@ -23232,6 +24284,10 @@
             <a:prstDash val="solid"/>
           </a:ln>
         </p:spPr>
+        <p:txBody>
+          <a:bodyPr/>
+          <a:p/>
+        </p:txBody>
       </p:sp>
       <p:sp>
         <p:nvSpPr>
@@ -23420,6 +24476,30 @@
           </a:p>
         </p:txBody>
       </p:sp>
+      <p:pic>
+        <p:nvPicPr>
+          <p:cNvPr id="11" name="IE University logo" descr="IE University, School of Science &amp; Technology"/>
+          <p:cNvPicPr>
+            <a:picLocks noChangeAspect="1"/>
+          </p:cNvPicPr>
+          <p:nvPr/>
+        </p:nvPicPr>
+        <p:blipFill>
+          <a:blip r:embed="rId3"/>
+          <a:stretch>
+            <a:fillRect/>
+          </a:stretch>
+        </p:blipFill>
+        <p:spPr>
+          <a:xfrm>
+            <a:off x="8013607" y="92634"/>
+            <a:ext cx="764633" cy="262789"/>
+          </a:xfrm>
+          <a:prstGeom prst="rect">
+            <a:avLst/>
+          </a:prstGeom>
+        </p:spPr>
+      </p:pic>
     </p:spTree>
   </p:cSld>
   <p:clrMapOvr>
@@ -23485,7 +24565,7 @@
                 <a:ea typeface="Calibri" pitchFamily="34" charset="-122"/>
                 <a:cs typeface="Calibri" pitchFamily="34" charset="-120"/>
               </a:rPr>
-              <a:t>Master in Business Analytics and Big Data</a:t>
+              <a:t>Master in Business Analytics and Data Science</a:t>
             </a:r>
             <a:endParaRPr lang="en-US" sz="900" dirty="0"/>
           </a:p>
@@ -23524,7 +24604,7 @@
                 <a:ea typeface="Calibri" pitchFamily="34" charset="-122"/>
                 <a:cs typeface="Calibri" pitchFamily="34" charset="-120"/>
               </a:rPr>
-              <a:t>MLOps · MBABD-PT 2026–27 · Session 3 · Juan Ramírez</a:t>
+              <a:t>MLOps · MBDS-PT2026F · Session 3 · Juan Ramírez</a:t>
             </a:r>
             <a:endParaRPr lang="en-US" sz="800" dirty="0"/>
           </a:p>
@@ -24990,6 +26070,10 @@
             <a:prstDash val="solid"/>
           </a:ln>
         </p:spPr>
+        <p:txBody>
+          <a:bodyPr/>
+          <a:p/>
+        </p:txBody>
       </p:sp>
       <p:pic>
         <p:nvPicPr>
@@ -25054,6 +26138,30 @@
           </a:p>
         </p:txBody>
       </p:sp>
+      <p:pic>
+        <p:nvPicPr>
+          <p:cNvPr id="31" name="IE University logo" descr="IE University, School of Science &amp; Technology"/>
+          <p:cNvPicPr>
+            <a:picLocks noChangeAspect="1"/>
+          </p:cNvPicPr>
+          <p:nvPr/>
+        </p:nvPicPr>
+        <p:blipFill>
+          <a:blip r:embed="rId4"/>
+          <a:stretch>
+            <a:fillRect/>
+          </a:stretch>
+        </p:blipFill>
+        <p:spPr>
+          <a:xfrm>
+            <a:off x="8013607" y="92634"/>
+            <a:ext cx="764633" cy="262789"/>
+          </a:xfrm>
+          <a:prstGeom prst="rect">
+            <a:avLst/>
+          </a:prstGeom>
+        </p:spPr>
+      </p:pic>
     </p:spTree>
   </p:cSld>
   <p:clrMapOvr>
@@ -25119,7 +26227,7 @@
                 <a:ea typeface="Calibri" pitchFamily="34" charset="-122"/>
                 <a:cs typeface="Calibri" pitchFamily="34" charset="-120"/>
               </a:rPr>
-              <a:t>Master in Business Analytics and Big Data</a:t>
+              <a:t>Master in Business Analytics and Data Science</a:t>
             </a:r>
             <a:endParaRPr lang="en-US" sz="900" dirty="0"/>
           </a:p>
@@ -25158,7 +26266,7 @@
                 <a:ea typeface="Calibri" pitchFamily="34" charset="-122"/>
                 <a:cs typeface="Calibri" pitchFamily="34" charset="-120"/>
               </a:rPr>
-              <a:t>MLOps · MBABD-PT 2026–27 · Session 3 · Juan Ramírez</a:t>
+              <a:t>MLOps · MBDS-PT2026F · Session 3 · Juan Ramírez</a:t>
             </a:r>
             <a:endParaRPr lang="en-US" sz="800" dirty="0"/>
           </a:p>
@@ -25268,6 +26376,10 @@
             <a:prstDash val="solid"/>
           </a:ln>
         </p:spPr>
+        <p:txBody>
+          <a:bodyPr/>
+          <a:p/>
+        </p:txBody>
       </p:sp>
       <p:sp>
         <p:nvSpPr>
@@ -25293,6 +26405,10 @@
             <a:prstDash val="solid"/>
           </a:ln>
         </p:spPr>
+        <p:txBody>
+          <a:bodyPr/>
+          <a:p/>
+        </p:txBody>
       </p:sp>
       <p:pic>
         <p:nvPicPr>
@@ -25489,6 +26605,10 @@
             <a:prstDash val="solid"/>
           </a:ln>
         </p:spPr>
+        <p:txBody>
+          <a:bodyPr/>
+          <a:p/>
+        </p:txBody>
       </p:sp>
       <p:sp>
         <p:nvSpPr>
@@ -25514,6 +26634,10 @@
             <a:prstDash val="solid"/>
           </a:ln>
         </p:spPr>
+        <p:txBody>
+          <a:bodyPr/>
+          <a:p/>
+        </p:txBody>
       </p:sp>
       <p:pic>
         <p:nvPicPr>
@@ -25710,6 +26834,10 @@
             <a:prstDash val="solid"/>
           </a:ln>
         </p:spPr>
+        <p:txBody>
+          <a:bodyPr/>
+          <a:p/>
+        </p:txBody>
       </p:sp>
       <p:sp>
         <p:nvSpPr>
@@ -25735,6 +26863,10 @@
             <a:prstDash val="solid"/>
           </a:ln>
         </p:spPr>
+        <p:txBody>
+          <a:bodyPr/>
+          <a:p/>
+        </p:txBody>
       </p:sp>
       <p:pic>
         <p:nvPicPr>
@@ -25931,6 +27063,10 @@
             <a:prstDash val="solid"/>
           </a:ln>
         </p:spPr>
+        <p:txBody>
+          <a:bodyPr/>
+          <a:p/>
+        </p:txBody>
       </p:sp>
       <p:pic>
         <p:nvPicPr>
@@ -25995,6 +27131,30 @@
           </a:p>
         </p:txBody>
       </p:sp>
+      <p:pic>
+        <p:nvPicPr>
+          <p:cNvPr id="25" name="IE University logo" descr="IE University, School of Science &amp; Technology"/>
+          <p:cNvPicPr>
+            <a:picLocks noChangeAspect="1"/>
+          </p:cNvPicPr>
+          <p:nvPr/>
+        </p:nvPicPr>
+        <p:blipFill>
+          <a:blip r:embed="rId7"/>
+          <a:stretch>
+            <a:fillRect/>
+          </a:stretch>
+        </p:blipFill>
+        <p:spPr>
+          <a:xfrm>
+            <a:off x="8013607" y="92634"/>
+            <a:ext cx="764633" cy="262789"/>
+          </a:xfrm>
+          <a:prstGeom prst="rect">
+            <a:avLst/>
+          </a:prstGeom>
+        </p:spPr>
+      </p:pic>
     </p:spTree>
   </p:cSld>
   <p:clrMapOvr>
@@ -26060,7 +27220,7 @@
                 <a:ea typeface="Calibri" pitchFamily="34" charset="-122"/>
                 <a:cs typeface="Calibri" pitchFamily="34" charset="-120"/>
               </a:rPr>
-              <a:t>Master in Business Analytics and Big Data</a:t>
+              <a:t>Master in Business Analytics and Data Science</a:t>
             </a:r>
             <a:endParaRPr lang="en-US" sz="900" dirty="0"/>
           </a:p>
@@ -26099,7 +27259,7 @@
                 <a:ea typeface="Calibri" pitchFamily="34" charset="-122"/>
                 <a:cs typeface="Calibri" pitchFamily="34" charset="-120"/>
               </a:rPr>
-              <a:t>MLOps · MBABD-PT 2026–27 · Session 3 · Juan Ramírez</a:t>
+              <a:t>MLOps · MBDS-PT2026F · Session 3 · Juan Ramírez</a:t>
             </a:r>
             <a:endParaRPr lang="en-US" sz="800" dirty="0"/>
           </a:p>
@@ -26207,6 +27367,10 @@
             <a:prstDash val="solid"/>
           </a:ln>
         </p:spPr>
+        <p:txBody>
+          <a:bodyPr/>
+          <a:p/>
+        </p:txBody>
       </p:sp>
       <p:sp>
         <p:nvSpPr>
@@ -26349,6 +27513,10 @@
             <a:prstDash val="solid"/>
           </a:ln>
         </p:spPr>
+        <p:txBody>
+          <a:bodyPr/>
+          <a:p/>
+        </p:txBody>
       </p:sp>
       <p:sp>
         <p:nvSpPr>
@@ -26491,6 +27659,10 @@
             <a:prstDash val="solid"/>
           </a:ln>
         </p:spPr>
+        <p:txBody>
+          <a:bodyPr/>
+          <a:p/>
+        </p:txBody>
       </p:sp>
       <p:sp>
         <p:nvSpPr>
@@ -26609,6 +27781,30 @@
           </a:p>
         </p:txBody>
       </p:sp>
+      <p:pic>
+        <p:nvPicPr>
+          <p:cNvPr id="19" name="IE University logo" descr="IE University, School of Science &amp; Technology"/>
+          <p:cNvPicPr>
+            <a:picLocks noChangeAspect="1"/>
+          </p:cNvPicPr>
+          <p:nvPr/>
+        </p:nvPicPr>
+        <p:blipFill>
+          <a:blip r:embed="rId3"/>
+          <a:stretch>
+            <a:fillRect/>
+          </a:stretch>
+        </p:blipFill>
+        <p:spPr>
+          <a:xfrm>
+            <a:off x="8013607" y="92634"/>
+            <a:ext cx="764633" cy="262789"/>
+          </a:xfrm>
+          <a:prstGeom prst="rect">
+            <a:avLst/>
+          </a:prstGeom>
+        </p:spPr>
+      </p:pic>
     </p:spTree>
   </p:cSld>
   <p:clrMapOvr>
@@ -26674,7 +27870,7 @@
                 <a:ea typeface="Calibri" pitchFamily="34" charset="-122"/>
                 <a:cs typeface="Calibri" pitchFamily="34" charset="-120"/>
               </a:rPr>
-              <a:t>Master in Business Analytics and Big Data</a:t>
+              <a:t>Master in Business Analytics and Data Science</a:t>
             </a:r>
             <a:endParaRPr lang="en-US" sz="900" dirty="0"/>
           </a:p>
@@ -26713,7 +27909,7 @@
                 <a:ea typeface="Calibri" pitchFamily="34" charset="-122"/>
                 <a:cs typeface="Calibri" pitchFamily="34" charset="-120"/>
               </a:rPr>
-              <a:t>MLOps · MBABD-PT 2026–27 · Session 3 · Juan Ramírez</a:t>
+              <a:t>MLOps · MBDS-PT2026F · Session 3 · Juan Ramírez</a:t>
             </a:r>
             <a:endParaRPr lang="en-US" sz="800" dirty="0"/>
           </a:p>
@@ -26821,6 +28017,10 @@
             <a:prstDash val="solid"/>
           </a:ln>
         </p:spPr>
+        <p:txBody>
+          <a:bodyPr/>
+          <a:p/>
+        </p:txBody>
       </p:sp>
       <p:sp>
         <p:nvSpPr>
@@ -26924,6 +28124,10 @@
             <a:prstDash val="solid"/>
           </a:ln>
         </p:spPr>
+        <p:txBody>
+          <a:bodyPr/>
+          <a:p/>
+        </p:txBody>
       </p:sp>
       <p:sp>
         <p:nvSpPr>
@@ -27027,6 +28231,10 @@
             <a:prstDash val="solid"/>
           </a:ln>
         </p:spPr>
+        <p:txBody>
+          <a:bodyPr/>
+          <a:p/>
+        </p:txBody>
       </p:sp>
       <p:sp>
         <p:nvSpPr>
@@ -27132,6 +28340,10 @@
             <a:prstDash val="solid"/>
           </a:ln>
         </p:spPr>
+        <p:txBody>
+          <a:bodyPr/>
+          <a:p/>
+        </p:txBody>
       </p:sp>
       <p:pic>
         <p:nvPicPr>
@@ -27196,6 +28408,30 @@
           </a:p>
         </p:txBody>
       </p:sp>
+      <p:pic>
+        <p:nvPicPr>
+          <p:cNvPr id="19" name="IE University logo" descr="IE University, School of Science &amp; Technology"/>
+          <p:cNvPicPr>
+            <a:picLocks noChangeAspect="1"/>
+          </p:cNvPicPr>
+          <p:nvPr/>
+        </p:nvPicPr>
+        <p:blipFill>
+          <a:blip r:embed="rId4"/>
+          <a:stretch>
+            <a:fillRect/>
+          </a:stretch>
+        </p:blipFill>
+        <p:spPr>
+          <a:xfrm>
+            <a:off x="8013607" y="92634"/>
+            <a:ext cx="764633" cy="262789"/>
+          </a:xfrm>
+          <a:prstGeom prst="rect">
+            <a:avLst/>
+          </a:prstGeom>
+        </p:spPr>
+      </p:pic>
     </p:spTree>
   </p:cSld>
   <p:clrMapOvr>
@@ -27261,7 +28497,7 @@
                 <a:ea typeface="Calibri" pitchFamily="34" charset="-122"/>
                 <a:cs typeface="Calibri" pitchFamily="34" charset="-120"/>
               </a:rPr>
-              <a:t>Master in Business Analytics and Big Data</a:t>
+              <a:t>Master in Business Analytics and Data Science</a:t>
             </a:r>
             <a:endParaRPr lang="en-US" sz="900" dirty="0"/>
           </a:p>
@@ -27300,7 +28536,7 @@
                 <a:ea typeface="Calibri" pitchFamily="34" charset="-122"/>
                 <a:cs typeface="Calibri" pitchFamily="34" charset="-120"/>
               </a:rPr>
-              <a:t>MLOps · MBABD-PT 2026–27 · Session 3 · Juan Ramírez</a:t>
+              <a:t>MLOps · MBDS-PT2026F · Session 3 · Juan Ramírez</a:t>
             </a:r>
             <a:endParaRPr lang="en-US" sz="800" dirty="0"/>
           </a:p>
@@ -27410,6 +28646,10 @@
             <a:prstDash val="solid"/>
           </a:ln>
         </p:spPr>
+        <p:txBody>
+          <a:bodyPr/>
+          <a:p/>
+        </p:txBody>
       </p:sp>
       <p:sp>
         <p:nvSpPr>
@@ -27435,6 +28675,10 @@
             <a:prstDash val="solid"/>
           </a:ln>
         </p:spPr>
+        <p:txBody>
+          <a:bodyPr/>
+          <a:p/>
+        </p:txBody>
       </p:sp>
       <p:pic>
         <p:nvPicPr>
@@ -27610,6 +28854,10 @@
             <a:prstDash val="solid"/>
           </a:ln>
         </p:spPr>
+        <p:txBody>
+          <a:bodyPr/>
+          <a:p/>
+        </p:txBody>
       </p:sp>
       <p:sp>
         <p:nvSpPr>
@@ -27635,6 +28883,10 @@
             <a:prstDash val="solid"/>
           </a:ln>
         </p:spPr>
+        <p:txBody>
+          <a:bodyPr/>
+          <a:p/>
+        </p:txBody>
       </p:sp>
       <p:pic>
         <p:nvPicPr>
@@ -27810,6 +29062,10 @@
             <a:prstDash val="solid"/>
           </a:ln>
         </p:spPr>
+        <p:txBody>
+          <a:bodyPr/>
+          <a:p/>
+        </p:txBody>
       </p:sp>
       <p:sp>
         <p:nvSpPr>
@@ -27889,6 +29145,30 @@
           </a:p>
         </p:txBody>
       </p:sp>
+      <p:pic>
+        <p:nvPicPr>
+          <p:cNvPr id="20" name="IE University logo" descr="IE University, School of Science &amp; Technology"/>
+          <p:cNvPicPr>
+            <a:picLocks noChangeAspect="1"/>
+          </p:cNvPicPr>
+          <p:nvPr/>
+        </p:nvPicPr>
+        <p:blipFill>
+          <a:blip r:embed="rId5"/>
+          <a:stretch>
+            <a:fillRect/>
+          </a:stretch>
+        </p:blipFill>
+        <p:spPr>
+          <a:xfrm>
+            <a:off x="8013607" y="92634"/>
+            <a:ext cx="764633" cy="262789"/>
+          </a:xfrm>
+          <a:prstGeom prst="rect">
+            <a:avLst/>
+          </a:prstGeom>
+        </p:spPr>
+      </p:pic>
     </p:spTree>
   </p:cSld>
   <p:clrMapOvr>
@@ -27954,7 +29234,7 @@
                 <a:ea typeface="Calibri" pitchFamily="34" charset="-122"/>
                 <a:cs typeface="Calibri" pitchFamily="34" charset="-120"/>
               </a:rPr>
-              <a:t>Master in Business Analytics and Big Data</a:t>
+              <a:t>Master in Business Analytics and Data Science</a:t>
             </a:r>
             <a:endParaRPr lang="en-US" sz="900" dirty="0"/>
           </a:p>
@@ -27993,7 +29273,7 @@
                 <a:ea typeface="Calibri" pitchFamily="34" charset="-122"/>
                 <a:cs typeface="Calibri" pitchFamily="34" charset="-120"/>
               </a:rPr>
-              <a:t>MLOps · MBABD-PT 2026–27 · Session 3 · Juan Ramírez</a:t>
+              <a:t>MLOps · MBDS-PT2026F · Session 3 · Juan Ramírez</a:t>
             </a:r>
             <a:endParaRPr lang="en-US" sz="800" dirty="0"/>
           </a:p>
@@ -28116,6 +29396,30 @@
           </a:p>
         </p:txBody>
       </p:sp>
+      <p:pic>
+        <p:nvPicPr>
+          <p:cNvPr id="7" name="IE University logo" descr="IE University, School of Science &amp; Technology"/>
+          <p:cNvPicPr>
+            <a:picLocks noChangeAspect="1"/>
+          </p:cNvPicPr>
+          <p:nvPr/>
+        </p:nvPicPr>
+        <p:blipFill>
+          <a:blip r:embed="rId3"/>
+          <a:stretch>
+            <a:fillRect/>
+          </a:stretch>
+        </p:blipFill>
+        <p:spPr>
+          <a:xfrm>
+            <a:off x="8252653" y="109728"/>
+            <a:ext cx="525587" cy="704395"/>
+          </a:xfrm>
+          <a:prstGeom prst="rect">
+            <a:avLst/>
+          </a:prstGeom>
+        </p:spPr>
+      </p:pic>
     </p:spTree>
   </p:cSld>
   <p:clrMapOvr>
@@ -28181,7 +29485,7 @@
                 <a:ea typeface="Calibri" pitchFamily="34" charset="-122"/>
                 <a:cs typeface="Calibri" pitchFamily="34" charset="-120"/>
               </a:rPr>
-              <a:t>Master in Business Analytics and Big Data</a:t>
+              <a:t>Master in Business Analytics and Data Science</a:t>
             </a:r>
             <a:endParaRPr lang="en-US" sz="900" dirty="0"/>
           </a:p>
@@ -28220,7 +29524,7 @@
                 <a:ea typeface="Calibri" pitchFamily="34" charset="-122"/>
                 <a:cs typeface="Calibri" pitchFamily="34" charset="-120"/>
               </a:rPr>
-              <a:t>MLOps · MBABD-PT 2026–27 · Session 3 · Juan Ramírez</a:t>
+              <a:t>MLOps · MBDS-PT2026F · Session 3 · Juan Ramírez</a:t>
             </a:r>
             <a:endParaRPr lang="en-US" sz="800" dirty="0"/>
           </a:p>
@@ -28330,6 +29634,10 @@
             <a:prstDash val="solid"/>
           </a:ln>
         </p:spPr>
+        <p:txBody>
+          <a:bodyPr/>
+          <a:p/>
+        </p:txBody>
       </p:sp>
       <p:sp>
         <p:nvSpPr>
@@ -28355,6 +29663,10 @@
             <a:prstDash val="solid"/>
           </a:ln>
         </p:spPr>
+        <p:txBody>
+          <a:bodyPr/>
+          <a:p/>
+        </p:txBody>
       </p:sp>
       <p:pic>
         <p:nvPicPr>
@@ -28530,6 +29842,10 @@
             <a:prstDash val="solid"/>
           </a:ln>
         </p:spPr>
+        <p:txBody>
+          <a:bodyPr/>
+          <a:p/>
+        </p:txBody>
       </p:sp>
       <p:sp>
         <p:nvSpPr>
@@ -28555,6 +29871,10 @@
             <a:prstDash val="solid"/>
           </a:ln>
         </p:spPr>
+        <p:txBody>
+          <a:bodyPr/>
+          <a:p/>
+        </p:txBody>
       </p:sp>
       <p:pic>
         <p:nvPicPr>
@@ -28704,6 +30024,30 @@
           </a:p>
         </p:txBody>
       </p:sp>
+      <p:pic>
+        <p:nvPicPr>
+          <p:cNvPr id="17" name="IE University logo" descr="IE University, School of Science &amp; Technology"/>
+          <p:cNvPicPr>
+            <a:picLocks noChangeAspect="1"/>
+          </p:cNvPicPr>
+          <p:nvPr/>
+        </p:nvPicPr>
+        <p:blipFill>
+          <a:blip r:embed="rId5"/>
+          <a:stretch>
+            <a:fillRect/>
+          </a:stretch>
+        </p:blipFill>
+        <p:spPr>
+          <a:xfrm>
+            <a:off x="8013607" y="92634"/>
+            <a:ext cx="764633" cy="262789"/>
+          </a:xfrm>
+          <a:prstGeom prst="rect">
+            <a:avLst/>
+          </a:prstGeom>
+        </p:spPr>
+      </p:pic>
     </p:spTree>
   </p:cSld>
   <p:clrMapOvr>
@@ -28769,7 +30113,7 @@
                 <a:ea typeface="Calibri" pitchFamily="34" charset="-122"/>
                 <a:cs typeface="Calibri" pitchFamily="34" charset="-120"/>
               </a:rPr>
-              <a:t>Master in Business Analytics and Big Data</a:t>
+              <a:t>Master in Business Analytics and Data Science</a:t>
             </a:r>
             <a:endParaRPr lang="en-US" sz="900" dirty="0"/>
           </a:p>
@@ -28808,7 +30152,7 @@
                 <a:ea typeface="Calibri" pitchFamily="34" charset="-122"/>
                 <a:cs typeface="Calibri" pitchFamily="34" charset="-120"/>
               </a:rPr>
-              <a:t>MLOps · MBABD-PT 2026–27 · Session 3 · Juan Ramírez</a:t>
+              <a:t>MLOps · MBDS-PT2026F · Session 3 · Juan Ramírez</a:t>
             </a:r>
             <a:endParaRPr lang="en-US" sz="800" dirty="0"/>
           </a:p>
@@ -28918,6 +30262,10 @@
             <a:prstDash val="solid"/>
           </a:ln>
         </p:spPr>
+        <p:txBody>
+          <a:bodyPr/>
+          <a:p/>
+        </p:txBody>
       </p:sp>
       <p:sp>
         <p:nvSpPr>
@@ -28943,6 +30291,10 @@
             <a:prstDash val="solid"/>
           </a:ln>
         </p:spPr>
+        <p:txBody>
+          <a:bodyPr/>
+          <a:p/>
+        </p:txBody>
       </p:sp>
       <p:pic>
         <p:nvPicPr>
@@ -29097,6 +30449,10 @@
             <a:prstDash val="solid"/>
           </a:ln>
         </p:spPr>
+        <p:txBody>
+          <a:bodyPr/>
+          <a:p/>
+        </p:txBody>
       </p:sp>
       <p:sp>
         <p:nvSpPr>
@@ -29122,6 +30478,10 @@
             <a:prstDash val="solid"/>
           </a:ln>
         </p:spPr>
+        <p:txBody>
+          <a:bodyPr/>
+          <a:p/>
+        </p:txBody>
       </p:sp>
       <p:pic>
         <p:nvPicPr>
@@ -29276,6 +30636,10 @@
             <a:prstDash val="solid"/>
           </a:ln>
         </p:spPr>
+        <p:txBody>
+          <a:bodyPr/>
+          <a:p/>
+        </p:txBody>
       </p:sp>
       <p:sp>
         <p:nvSpPr>
@@ -29301,6 +30665,10 @@
             <a:prstDash val="solid"/>
           </a:ln>
         </p:spPr>
+        <p:txBody>
+          <a:bodyPr/>
+          <a:p/>
+        </p:txBody>
       </p:sp>
       <p:pic>
         <p:nvPicPr>
@@ -29450,6 +30818,30 @@
           </a:p>
         </p:txBody>
       </p:sp>
+      <p:pic>
+        <p:nvPicPr>
+          <p:cNvPr id="22" name="IE University logo" descr="IE University, School of Science &amp; Technology"/>
+          <p:cNvPicPr>
+            <a:picLocks noChangeAspect="1"/>
+          </p:cNvPicPr>
+          <p:nvPr/>
+        </p:nvPicPr>
+        <p:blipFill>
+          <a:blip r:embed="rId6"/>
+          <a:stretch>
+            <a:fillRect/>
+          </a:stretch>
+        </p:blipFill>
+        <p:spPr>
+          <a:xfrm>
+            <a:off x="8013607" y="92634"/>
+            <a:ext cx="764633" cy="262789"/>
+          </a:xfrm>
+          <a:prstGeom prst="rect">
+            <a:avLst/>
+          </a:prstGeom>
+        </p:spPr>
+      </p:pic>
     </p:spTree>
   </p:cSld>
   <p:clrMapOvr>
@@ -29515,7 +30907,7 @@
                 <a:ea typeface="Calibri" pitchFamily="34" charset="-122"/>
                 <a:cs typeface="Calibri" pitchFamily="34" charset="-120"/>
               </a:rPr>
-              <a:t>Master in Business Analytics and Big Data</a:t>
+              <a:t>Master in Business Analytics and Data Science</a:t>
             </a:r>
             <a:endParaRPr lang="en-US" sz="900" dirty="0"/>
           </a:p>
@@ -29554,7 +30946,7 @@
                 <a:ea typeface="Calibri" pitchFamily="34" charset="-122"/>
                 <a:cs typeface="Calibri" pitchFamily="34" charset="-120"/>
               </a:rPr>
-              <a:t>MLOps · MBABD-PT 2026–27 · Session 3 · Juan Ramírez</a:t>
+              <a:t>MLOps · MBDS-PT2026F · Session 3 · Juan Ramírez</a:t>
             </a:r>
             <a:endParaRPr lang="en-US" sz="800" dirty="0"/>
           </a:p>
@@ -29664,6 +31056,10 @@
             <a:prstDash val="solid"/>
           </a:ln>
         </p:spPr>
+        <p:txBody>
+          <a:bodyPr/>
+          <a:p/>
+        </p:txBody>
       </p:sp>
       <p:sp>
         <p:nvSpPr>
@@ -29689,6 +31085,10 @@
             <a:prstDash val="solid"/>
           </a:ln>
         </p:spPr>
+        <p:txBody>
+          <a:bodyPr/>
+          <a:p/>
+        </p:txBody>
       </p:sp>
       <p:pic>
         <p:nvPicPr>
@@ -29885,6 +31285,10 @@
             <a:prstDash val="solid"/>
           </a:ln>
         </p:spPr>
+        <p:txBody>
+          <a:bodyPr/>
+          <a:p/>
+        </p:txBody>
       </p:sp>
       <p:sp>
         <p:nvSpPr>
@@ -29910,6 +31314,10 @@
             <a:prstDash val="solid"/>
           </a:ln>
         </p:spPr>
+        <p:txBody>
+          <a:bodyPr/>
+          <a:p/>
+        </p:txBody>
       </p:sp>
       <p:pic>
         <p:nvPicPr>
@@ -30080,6 +31488,30 @@
           </a:p>
         </p:txBody>
       </p:sp>
+      <p:pic>
+        <p:nvPicPr>
+          <p:cNvPr id="17" name="IE University logo" descr="IE University, School of Science &amp; Technology"/>
+          <p:cNvPicPr>
+            <a:picLocks noChangeAspect="1"/>
+          </p:cNvPicPr>
+          <p:nvPr/>
+        </p:nvPicPr>
+        <p:blipFill>
+          <a:blip r:embed="rId5"/>
+          <a:stretch>
+            <a:fillRect/>
+          </a:stretch>
+        </p:blipFill>
+        <p:spPr>
+          <a:xfrm>
+            <a:off x="8013607" y="92634"/>
+            <a:ext cx="764633" cy="262789"/>
+          </a:xfrm>
+          <a:prstGeom prst="rect">
+            <a:avLst/>
+          </a:prstGeom>
+        </p:spPr>
+      </p:pic>
     </p:spTree>
   </p:cSld>
   <p:clrMapOvr>
@@ -30145,7 +31577,7 @@
                 <a:ea typeface="Calibri" pitchFamily="34" charset="-122"/>
                 <a:cs typeface="Calibri" pitchFamily="34" charset="-120"/>
               </a:rPr>
-              <a:t>Master in Business Analytics and Big Data</a:t>
+              <a:t>Master in Business Analytics and Data Science</a:t>
             </a:r>
             <a:endParaRPr lang="en-US" sz="900" dirty="0"/>
           </a:p>
@@ -30184,7 +31616,7 @@
                 <a:ea typeface="Calibri" pitchFamily="34" charset="-122"/>
                 <a:cs typeface="Calibri" pitchFamily="34" charset="-120"/>
               </a:rPr>
-              <a:t>MLOps · MBABD-PT 2026–27 · Session 3 · Juan Ramírez</a:t>
+              <a:t>MLOps · MBDS-PT2026F · Session 3 · Juan Ramírez</a:t>
             </a:r>
             <a:endParaRPr lang="en-US" sz="800" dirty="0"/>
           </a:p>
@@ -30292,6 +31724,10 @@
             <a:prstDash val="solid"/>
           </a:ln>
         </p:spPr>
+        <p:txBody>
+          <a:bodyPr/>
+          <a:p/>
+        </p:txBody>
       </p:sp>
       <p:sp>
         <p:nvSpPr>
@@ -30434,6 +31870,10 @@
             <a:prstDash val="solid"/>
           </a:ln>
         </p:spPr>
+        <p:txBody>
+          <a:bodyPr/>
+          <a:p/>
+        </p:txBody>
       </p:sp>
       <p:sp>
         <p:nvSpPr>
@@ -30576,6 +32016,10 @@
             <a:prstDash val="solid"/>
           </a:ln>
         </p:spPr>
+        <p:txBody>
+          <a:bodyPr/>
+          <a:p/>
+        </p:txBody>
       </p:sp>
       <p:sp>
         <p:nvSpPr>
@@ -30694,6 +32138,30 @@
           </a:p>
         </p:txBody>
       </p:sp>
+      <p:pic>
+        <p:nvPicPr>
+          <p:cNvPr id="19" name="IE University logo" descr="IE University, School of Science &amp; Technology"/>
+          <p:cNvPicPr>
+            <a:picLocks noChangeAspect="1"/>
+          </p:cNvPicPr>
+          <p:nvPr/>
+        </p:nvPicPr>
+        <p:blipFill>
+          <a:blip r:embed="rId3"/>
+          <a:stretch>
+            <a:fillRect/>
+          </a:stretch>
+        </p:blipFill>
+        <p:spPr>
+          <a:xfrm>
+            <a:off x="8013607" y="92634"/>
+            <a:ext cx="764633" cy="262789"/>
+          </a:xfrm>
+          <a:prstGeom prst="rect">
+            <a:avLst/>
+          </a:prstGeom>
+        </p:spPr>
+      </p:pic>
     </p:spTree>
   </p:cSld>
   <p:clrMapOvr>
@@ -30759,7 +32227,7 @@
                 <a:ea typeface="Calibri" pitchFamily="34" charset="-122"/>
                 <a:cs typeface="Calibri" pitchFamily="34" charset="-120"/>
               </a:rPr>
-              <a:t>Master in Business Analytics and Big Data</a:t>
+              <a:t>Master in Business Analytics and Data Science</a:t>
             </a:r>
             <a:endParaRPr lang="en-US" sz="900" dirty="0"/>
           </a:p>
@@ -30798,7 +32266,7 @@
                 <a:ea typeface="Calibri" pitchFamily="34" charset="-122"/>
                 <a:cs typeface="Calibri" pitchFamily="34" charset="-120"/>
               </a:rPr>
-              <a:t>MLOps · MBABD-PT 2026–27 · Session 3 · Juan Ramírez</a:t>
+              <a:t>MLOps · MBDS-PT2026F · Session 3 · Juan Ramírez</a:t>
             </a:r>
             <a:endParaRPr lang="en-US" sz="800" dirty="0"/>
           </a:p>
@@ -30947,6 +32415,10 @@
             <a:prstDash val="solid"/>
           </a:ln>
         </p:spPr>
+        <p:txBody>
+          <a:bodyPr/>
+          <a:p/>
+        </p:txBody>
       </p:sp>
       <p:sp>
         <p:nvSpPr>
@@ -31200,6 +32672,10 @@
             <a:prstDash val="solid"/>
           </a:ln>
         </p:spPr>
+        <p:txBody>
+          <a:bodyPr/>
+          <a:p/>
+        </p:txBody>
       </p:sp>
       <p:sp>
         <p:nvSpPr>
@@ -31517,6 +32993,30 @@
           </a:p>
         </p:txBody>
       </p:sp>
+      <p:pic>
+        <p:nvPicPr>
+          <p:cNvPr id="14" name="IE University logo" descr="IE University, School of Science &amp; Technology"/>
+          <p:cNvPicPr>
+            <a:picLocks noChangeAspect="1"/>
+          </p:cNvPicPr>
+          <p:nvPr/>
+        </p:nvPicPr>
+        <p:blipFill>
+          <a:blip r:embed="rId3"/>
+          <a:stretch>
+            <a:fillRect/>
+          </a:stretch>
+        </p:blipFill>
+        <p:spPr>
+          <a:xfrm>
+            <a:off x="8013607" y="92634"/>
+            <a:ext cx="764633" cy="262789"/>
+          </a:xfrm>
+          <a:prstGeom prst="rect">
+            <a:avLst/>
+          </a:prstGeom>
+        </p:spPr>
+      </p:pic>
     </p:spTree>
   </p:cSld>
   <p:clrMapOvr>
@@ -31582,7 +33082,7 @@
                 <a:ea typeface="Calibri" pitchFamily="34" charset="-122"/>
                 <a:cs typeface="Calibri" pitchFamily="34" charset="-120"/>
               </a:rPr>
-              <a:t>Master in Business Analytics and Big Data</a:t>
+              <a:t>Master in Business Analytics and Data Science</a:t>
             </a:r>
             <a:endParaRPr lang="en-US" sz="900" dirty="0"/>
           </a:p>
@@ -31621,7 +33121,7 @@
                 <a:ea typeface="Calibri" pitchFamily="34" charset="-122"/>
                 <a:cs typeface="Calibri" pitchFamily="34" charset="-120"/>
               </a:rPr>
-              <a:t>MLOps · MBABD-PT 2026–27 · Session 3 · Juan Ramírez</a:t>
+              <a:t>MLOps · MBDS-PT2026F · Session 3 · Juan Ramírez</a:t>
             </a:r>
             <a:endParaRPr lang="en-US" sz="800" dirty="0"/>
           </a:p>
@@ -32861,6 +34361,10 @@
             <a:prstDash val="solid"/>
           </a:ln>
         </p:spPr>
+        <p:txBody>
+          <a:bodyPr/>
+          <a:p/>
+        </p:txBody>
       </p:sp>
       <p:sp>
         <p:nvSpPr>
@@ -32927,6 +34431,10 @@
             <a:prstDash val="solid"/>
           </a:ln>
         </p:spPr>
+        <p:txBody>
+          <a:bodyPr/>
+          <a:p/>
+        </p:txBody>
       </p:sp>
       <p:sp>
         <p:nvSpPr>
@@ -33006,6 +34514,30 @@
           </a:p>
         </p:txBody>
       </p:sp>
+      <p:pic>
+        <p:nvPicPr>
+          <p:cNvPr id="13" name="IE University logo" descr="IE University, School of Science &amp; Technology"/>
+          <p:cNvPicPr>
+            <a:picLocks noChangeAspect="1"/>
+          </p:cNvPicPr>
+          <p:nvPr/>
+        </p:nvPicPr>
+        <p:blipFill>
+          <a:blip r:embed="rId3"/>
+          <a:stretch>
+            <a:fillRect/>
+          </a:stretch>
+        </p:blipFill>
+        <p:spPr>
+          <a:xfrm>
+            <a:off x="8013607" y="92634"/>
+            <a:ext cx="764633" cy="262789"/>
+          </a:xfrm>
+          <a:prstGeom prst="rect">
+            <a:avLst/>
+          </a:prstGeom>
+        </p:spPr>
+      </p:pic>
     </p:spTree>
   </p:cSld>
   <p:clrMapOvr>
@@ -33071,7 +34603,7 @@
                 <a:ea typeface="Calibri" pitchFamily="34" charset="-122"/>
                 <a:cs typeface="Calibri" pitchFamily="34" charset="-120"/>
               </a:rPr>
-              <a:t>Master in Business Analytics and Big Data</a:t>
+              <a:t>Master in Business Analytics and Data Science</a:t>
             </a:r>
             <a:endParaRPr lang="en-US" sz="900" dirty="0"/>
           </a:p>
@@ -33110,7 +34642,7 @@
                 <a:ea typeface="Calibri" pitchFamily="34" charset="-122"/>
                 <a:cs typeface="Calibri" pitchFamily="34" charset="-120"/>
               </a:rPr>
-              <a:t>MLOps · MBABD-PT 2026–27 · Session 3 · Juan Ramírez</a:t>
+              <a:t>MLOps · MBDS-PT2026F · Session 3 · Juan Ramírez</a:t>
             </a:r>
             <a:endParaRPr lang="en-US" sz="800" dirty="0"/>
           </a:p>
@@ -33259,6 +34791,10 @@
             <a:prstDash val="solid"/>
           </a:ln>
         </p:spPr>
+        <p:txBody>
+          <a:bodyPr/>
+          <a:p/>
+        </p:txBody>
       </p:sp>
       <p:sp>
         <p:nvSpPr>
@@ -33325,6 +34861,10 @@
             <a:prstDash val="solid"/>
           </a:ln>
         </p:spPr>
+        <p:txBody>
+          <a:bodyPr/>
+          <a:p/>
+        </p:txBody>
       </p:sp>
       <p:sp>
         <p:nvSpPr>
@@ -33391,6 +34931,10 @@
             <a:prstDash val="solid"/>
           </a:ln>
         </p:spPr>
+        <p:txBody>
+          <a:bodyPr/>
+          <a:p/>
+        </p:txBody>
       </p:sp>
       <p:sp>
         <p:nvSpPr>
@@ -33457,6 +35001,10 @@
             <a:prstDash val="solid"/>
           </a:ln>
         </p:spPr>
+        <p:txBody>
+          <a:bodyPr/>
+          <a:p/>
+        </p:txBody>
       </p:sp>
       <p:sp>
         <p:nvSpPr>
@@ -33523,6 +35071,10 @@
             <a:prstDash val="solid"/>
           </a:ln>
         </p:spPr>
+        <p:txBody>
+          <a:bodyPr/>
+          <a:p/>
+        </p:txBody>
       </p:sp>
       <p:sp>
         <p:nvSpPr>
@@ -33589,6 +35141,10 @@
             <a:prstDash val="solid"/>
           </a:ln>
         </p:spPr>
+        <p:txBody>
+          <a:bodyPr/>
+          <a:p/>
+        </p:txBody>
       </p:sp>
       <p:sp>
         <p:nvSpPr>
@@ -33655,6 +35211,10 @@
             <a:prstDash val="solid"/>
           </a:ln>
         </p:spPr>
+        <p:txBody>
+          <a:bodyPr/>
+          <a:p/>
+        </p:txBody>
       </p:sp>
       <p:sp>
         <p:nvSpPr>
@@ -33721,6 +35281,10 @@
             <a:prstDash val="solid"/>
           </a:ln>
         </p:spPr>
+        <p:txBody>
+          <a:bodyPr/>
+          <a:p/>
+        </p:txBody>
       </p:sp>
       <p:sp>
         <p:nvSpPr>
@@ -33787,6 +35351,10 @@
             <a:prstDash val="solid"/>
           </a:ln>
         </p:spPr>
+        <p:txBody>
+          <a:bodyPr/>
+          <a:p/>
+        </p:txBody>
       </p:sp>
       <p:sp>
         <p:nvSpPr>
@@ -33866,6 +35434,30 @@
           </a:p>
         </p:txBody>
       </p:sp>
+      <p:pic>
+        <p:nvPicPr>
+          <p:cNvPr id="26" name="IE University logo" descr="IE University, School of Science &amp; Technology"/>
+          <p:cNvPicPr>
+            <a:picLocks noChangeAspect="1"/>
+          </p:cNvPicPr>
+          <p:nvPr/>
+        </p:nvPicPr>
+        <p:blipFill>
+          <a:blip r:embed="rId3"/>
+          <a:stretch>
+            <a:fillRect/>
+          </a:stretch>
+        </p:blipFill>
+        <p:spPr>
+          <a:xfrm>
+            <a:off x="8252653" y="109728"/>
+            <a:ext cx="525587" cy="704395"/>
+          </a:xfrm>
+          <a:prstGeom prst="rect">
+            <a:avLst/>
+          </a:prstGeom>
+        </p:spPr>
+      </p:pic>
     </p:spTree>
   </p:cSld>
   <p:clrMapOvr>
@@ -33931,7 +35523,7 @@
                 <a:ea typeface="Calibri" pitchFamily="34" charset="-122"/>
                 <a:cs typeface="Calibri" pitchFamily="34" charset="-120"/>
               </a:rPr>
-              <a:t>Master in Business Analytics and Big Data</a:t>
+              <a:t>Master in Business Analytics and Data Science</a:t>
             </a:r>
             <a:endParaRPr lang="en-US" sz="900" dirty="0"/>
           </a:p>
@@ -33970,7 +35562,7 @@
                 <a:ea typeface="Calibri" pitchFamily="34" charset="-122"/>
                 <a:cs typeface="Calibri" pitchFamily="34" charset="-120"/>
               </a:rPr>
-              <a:t>MLOps · MBABD-PT 2026–27 · Session 3 · Juan Ramírez</a:t>
+              <a:t>MLOps · MBDS-PT2026F · Session 3 · Juan Ramírez</a:t>
             </a:r>
             <a:endParaRPr lang="en-US" sz="800" dirty="0"/>
           </a:p>
@@ -34080,6 +35672,10 @@
             <a:prstDash val="solid"/>
           </a:ln>
         </p:spPr>
+        <p:txBody>
+          <a:bodyPr/>
+          <a:p/>
+        </p:txBody>
       </p:sp>
       <p:sp>
         <p:nvSpPr>
@@ -34185,6 +35781,10 @@
             <a:prstDash val="solid"/>
           </a:ln>
         </p:spPr>
+        <p:txBody>
+          <a:bodyPr/>
+          <a:p/>
+        </p:txBody>
       </p:sp>
       <p:sp>
         <p:nvSpPr>
@@ -34290,6 +35890,10 @@
             <a:prstDash val="solid"/>
           </a:ln>
         </p:spPr>
+        <p:txBody>
+          <a:bodyPr/>
+          <a:p/>
+        </p:txBody>
       </p:sp>
       <p:sp>
         <p:nvSpPr>
@@ -34353,6 +35957,10 @@
             <a:tailEnd type="triangle"/>
           </a:ln>
         </p:spPr>
+        <p:txBody>
+          <a:bodyPr/>
+          <a:p/>
+        </p:txBody>
       </p:sp>
       <p:sp>
         <p:nvSpPr>
@@ -34380,6 +35988,10 @@
             <a:prstDash val="solid"/>
           </a:ln>
         </p:spPr>
+        <p:txBody>
+          <a:bodyPr/>
+          <a:p/>
+        </p:txBody>
       </p:sp>
       <p:sp>
         <p:nvSpPr>
@@ -34443,6 +36055,10 @@
             <a:tailEnd type="triangle"/>
           </a:ln>
         </p:spPr>
+        <p:txBody>
+          <a:bodyPr/>
+          <a:p/>
+        </p:txBody>
       </p:sp>
       <p:sp>
         <p:nvSpPr>
@@ -34470,6 +36086,10 @@
             <a:prstDash val="solid"/>
           </a:ln>
         </p:spPr>
+        <p:txBody>
+          <a:bodyPr/>
+          <a:p/>
+        </p:txBody>
       </p:sp>
       <p:sp>
         <p:nvSpPr>
@@ -34533,6 +36153,10 @@
             <a:tailEnd type="triangle"/>
           </a:ln>
         </p:spPr>
+        <p:txBody>
+          <a:bodyPr/>
+          <a:p/>
+        </p:txBody>
       </p:sp>
       <p:sp>
         <p:nvSpPr>
@@ -34560,6 +36184,10 @@
             <a:prstDash val="solid"/>
           </a:ln>
         </p:spPr>
+        <p:txBody>
+          <a:bodyPr/>
+          <a:p/>
+        </p:txBody>
       </p:sp>
       <p:sp>
         <p:nvSpPr>
@@ -34626,6 +36254,10 @@
             <a:prstDash val="solid"/>
           </a:ln>
         </p:spPr>
+        <p:txBody>
+          <a:bodyPr/>
+          <a:p/>
+        </p:txBody>
       </p:sp>
       <p:pic>
         <p:nvPicPr>
@@ -34690,6 +36322,30 @@
           </a:p>
         </p:txBody>
       </p:sp>
+      <p:pic>
+        <p:nvPicPr>
+          <p:cNvPr id="27" name="IE University logo" descr="IE University, School of Science &amp; Technology"/>
+          <p:cNvPicPr>
+            <a:picLocks noChangeAspect="1"/>
+          </p:cNvPicPr>
+          <p:nvPr/>
+        </p:nvPicPr>
+        <p:blipFill>
+          <a:blip r:embed="rId4"/>
+          <a:stretch>
+            <a:fillRect/>
+          </a:stretch>
+        </p:blipFill>
+        <p:spPr>
+          <a:xfrm>
+            <a:off x="8013607" y="92634"/>
+            <a:ext cx="764633" cy="262789"/>
+          </a:xfrm>
+          <a:prstGeom prst="rect">
+            <a:avLst/>
+          </a:prstGeom>
+        </p:spPr>
+      </p:pic>
     </p:spTree>
   </p:cSld>
   <p:clrMapOvr>
@@ -34755,7 +36411,7 @@
                 <a:ea typeface="Calibri" pitchFamily="34" charset="-122"/>
                 <a:cs typeface="Calibri" pitchFamily="34" charset="-120"/>
               </a:rPr>
-              <a:t>Master in Business Analytics and Big Data</a:t>
+              <a:t>Master in Business Analytics and Data Science</a:t>
             </a:r>
             <a:endParaRPr lang="en-US" sz="900" dirty="0"/>
           </a:p>
@@ -34794,7 +36450,7 @@
                 <a:ea typeface="Calibri" pitchFamily="34" charset="-122"/>
                 <a:cs typeface="Calibri" pitchFamily="34" charset="-120"/>
               </a:rPr>
-              <a:t>MLOps · MBABD-PT 2026–27 · Session 3 · Juan Ramírez</a:t>
+              <a:t>MLOps · MBDS-PT2026F · Session 3 · Juan Ramírez</a:t>
             </a:r>
             <a:endParaRPr lang="en-US" sz="800" dirty="0"/>
           </a:p>
@@ -34943,6 +36599,10 @@
             <a:prstDash val="solid"/>
           </a:ln>
         </p:spPr>
+        <p:txBody>
+          <a:bodyPr/>
+          <a:p/>
+        </p:txBody>
       </p:sp>
       <p:sp>
         <p:nvSpPr>
@@ -35009,6 +36669,10 @@
             <a:prstDash val="solid"/>
           </a:ln>
         </p:spPr>
+        <p:txBody>
+          <a:bodyPr/>
+          <a:p/>
+        </p:txBody>
       </p:sp>
       <p:sp>
         <p:nvSpPr>
@@ -35075,6 +36739,10 @@
             <a:prstDash val="solid"/>
           </a:ln>
         </p:spPr>
+        <p:txBody>
+          <a:bodyPr/>
+          <a:p/>
+        </p:txBody>
       </p:sp>
       <p:sp>
         <p:nvSpPr>
@@ -35141,6 +36809,10 @@
             <a:prstDash val="solid"/>
           </a:ln>
         </p:spPr>
+        <p:txBody>
+          <a:bodyPr/>
+          <a:p/>
+        </p:txBody>
       </p:sp>
       <p:sp>
         <p:nvSpPr>
@@ -35207,6 +36879,10 @@
             <a:prstDash val="solid"/>
           </a:ln>
         </p:spPr>
+        <p:txBody>
+          <a:bodyPr/>
+          <a:p/>
+        </p:txBody>
       </p:sp>
       <p:sp>
         <p:nvSpPr>
@@ -35273,6 +36949,10 @@
             <a:prstDash val="solid"/>
           </a:ln>
         </p:spPr>
+        <p:txBody>
+          <a:bodyPr/>
+          <a:p/>
+        </p:txBody>
       </p:sp>
       <p:sp>
         <p:nvSpPr>
@@ -35339,6 +37019,10 @@
             <a:prstDash val="solid"/>
           </a:ln>
         </p:spPr>
+        <p:txBody>
+          <a:bodyPr/>
+          <a:p/>
+        </p:txBody>
       </p:sp>
       <p:sp>
         <p:nvSpPr>
@@ -35405,6 +37089,10 @@
             <a:prstDash val="solid"/>
           </a:ln>
         </p:spPr>
+        <p:txBody>
+          <a:bodyPr/>
+          <a:p/>
+        </p:txBody>
       </p:sp>
       <p:sp>
         <p:nvSpPr>
@@ -35471,6 +37159,10 @@
             <a:prstDash val="solid"/>
           </a:ln>
         </p:spPr>
+        <p:txBody>
+          <a:bodyPr/>
+          <a:p/>
+        </p:txBody>
       </p:sp>
       <p:sp>
         <p:nvSpPr>
@@ -35537,6 +37229,10 @@
             <a:prstDash val="solid"/>
           </a:ln>
         </p:spPr>
+        <p:txBody>
+          <a:bodyPr/>
+          <a:p/>
+        </p:txBody>
       </p:sp>
       <p:sp>
         <p:nvSpPr>
@@ -35603,6 +37299,10 @@
             <a:prstDash val="solid"/>
           </a:ln>
         </p:spPr>
+        <p:txBody>
+          <a:bodyPr/>
+          <a:p/>
+        </p:txBody>
       </p:sp>
       <p:sp>
         <p:nvSpPr>
@@ -35669,6 +37369,10 @@
             <a:prstDash val="solid"/>
           </a:ln>
         </p:spPr>
+        <p:txBody>
+          <a:bodyPr/>
+          <a:p/>
+        </p:txBody>
       </p:sp>
       <p:sp>
         <p:nvSpPr>
@@ -35732,6 +37436,10 @@
             <a:tailEnd type="triangle"/>
           </a:ln>
         </p:spPr>
+        <p:txBody>
+          <a:bodyPr/>
+          <a:p/>
+        </p:txBody>
       </p:sp>
       <p:sp>
         <p:nvSpPr>
@@ -35756,6 +37464,10 @@
             <a:tailEnd type="triangle"/>
           </a:ln>
         </p:spPr>
+        <p:txBody>
+          <a:bodyPr/>
+          <a:p/>
+        </p:txBody>
       </p:sp>
       <p:sp>
         <p:nvSpPr>
@@ -35780,6 +37492,10 @@
             <a:tailEnd type="triangle"/>
           </a:ln>
         </p:spPr>
+        <p:txBody>
+          <a:bodyPr/>
+          <a:p/>
+        </p:txBody>
       </p:sp>
       <p:sp>
         <p:nvSpPr>
@@ -35804,6 +37520,10 @@
             <a:tailEnd type="triangle"/>
           </a:ln>
         </p:spPr>
+        <p:txBody>
+          <a:bodyPr/>
+          <a:p/>
+        </p:txBody>
       </p:sp>
       <p:sp>
         <p:nvSpPr>
@@ -35909,6 +37629,10 @@
             <a:prstDash val="solid"/>
           </a:ln>
         </p:spPr>
+        <p:txBody>
+          <a:bodyPr/>
+          <a:p/>
+        </p:txBody>
       </p:sp>
       <p:sp>
         <p:nvSpPr>
@@ -36011,6 +37735,10 @@
             <a:tailEnd type="triangle"/>
           </a:ln>
         </p:spPr>
+        <p:txBody>
+          <a:bodyPr/>
+          <a:p/>
+        </p:txBody>
       </p:sp>
       <p:sp>
         <p:nvSpPr>
@@ -36038,6 +37766,10 @@
             <a:prstDash val="solid"/>
           </a:ln>
         </p:spPr>
+        <p:txBody>
+          <a:bodyPr/>
+          <a:p/>
+        </p:txBody>
       </p:sp>
       <p:sp>
         <p:nvSpPr>
@@ -36140,6 +37872,10 @@
             <a:tailEnd type="triangle"/>
           </a:ln>
         </p:spPr>
+        <p:txBody>
+          <a:bodyPr/>
+          <a:p/>
+        </p:txBody>
       </p:sp>
       <p:sp>
         <p:nvSpPr>
@@ -36167,6 +37903,10 @@
             <a:prstDash val="solid"/>
           </a:ln>
         </p:spPr>
+        <p:txBody>
+          <a:bodyPr/>
+          <a:p/>
+        </p:txBody>
       </p:sp>
       <p:sp>
         <p:nvSpPr>
@@ -36269,6 +38009,10 @@
             <a:tailEnd type="triangle"/>
           </a:ln>
         </p:spPr>
+        <p:txBody>
+          <a:bodyPr/>
+          <a:p/>
+        </p:txBody>
       </p:sp>
       <p:sp>
         <p:nvSpPr>
@@ -36296,6 +38040,10 @@
             <a:prstDash val="solid"/>
           </a:ln>
         </p:spPr>
+        <p:txBody>
+          <a:bodyPr/>
+          <a:p/>
+        </p:txBody>
       </p:sp>
       <p:sp>
         <p:nvSpPr>
@@ -36401,6 +38149,10 @@
             <a:prstDash val="solid"/>
           </a:ln>
         </p:spPr>
+        <p:txBody>
+          <a:bodyPr/>
+          <a:p/>
+        </p:txBody>
       </p:sp>
       <p:pic>
         <p:nvPicPr>
@@ -36465,6 +38217,30 @@
           </a:p>
         </p:txBody>
       </p:sp>
+      <p:pic>
+        <p:nvPicPr>
+          <p:cNvPr id="56" name="IE University logo" descr="IE University, School of Science &amp; Technology"/>
+          <p:cNvPicPr>
+            <a:picLocks noChangeAspect="1"/>
+          </p:cNvPicPr>
+          <p:nvPr/>
+        </p:nvPicPr>
+        <p:blipFill>
+          <a:blip r:embed="rId4"/>
+          <a:stretch>
+            <a:fillRect/>
+          </a:stretch>
+        </p:blipFill>
+        <p:spPr>
+          <a:xfrm>
+            <a:off x="8013607" y="92634"/>
+            <a:ext cx="764633" cy="262789"/>
+          </a:xfrm>
+          <a:prstGeom prst="rect">
+            <a:avLst/>
+          </a:prstGeom>
+        </p:spPr>
+      </p:pic>
     </p:spTree>
   </p:cSld>
   <p:clrMapOvr>
@@ -36530,7 +38306,7 @@
                 <a:ea typeface="Calibri" pitchFamily="34" charset="-122"/>
                 <a:cs typeface="Calibri" pitchFamily="34" charset="-120"/>
               </a:rPr>
-              <a:t>Master in Business Analytics and Big Data</a:t>
+              <a:t>Master in Business Analytics and Data Science</a:t>
             </a:r>
             <a:endParaRPr lang="en-US" sz="900" dirty="0"/>
           </a:p>
@@ -36569,7 +38345,7 @@
                 <a:ea typeface="Calibri" pitchFamily="34" charset="-122"/>
                 <a:cs typeface="Calibri" pitchFamily="34" charset="-120"/>
               </a:rPr>
-              <a:t>MLOps · MBABD-PT 2026–27 · Session 3 · Juan Ramírez</a:t>
+              <a:t>MLOps · MBDS-PT2026F · Session 3 · Juan Ramírez</a:t>
             </a:r>
             <a:endParaRPr lang="en-US" sz="800" dirty="0"/>
           </a:p>
@@ -36677,6 +38453,10 @@
             <a:prstDash val="solid"/>
           </a:ln>
         </p:spPr>
+        <p:txBody>
+          <a:bodyPr/>
+          <a:p/>
+        </p:txBody>
       </p:sp>
       <p:pic>
         <p:nvPicPr>
@@ -36804,6 +38584,10 @@
             <a:prstDash val="solid"/>
           </a:ln>
         </p:spPr>
+        <p:txBody>
+          <a:bodyPr/>
+          <a:p/>
+        </p:txBody>
       </p:sp>
       <p:pic>
         <p:nvPicPr>
@@ -36931,6 +38715,10 @@
             <a:prstDash val="solid"/>
           </a:ln>
         </p:spPr>
+        <p:txBody>
+          <a:bodyPr/>
+          <a:p/>
+        </p:txBody>
       </p:sp>
       <p:pic>
         <p:nvPicPr>
@@ -37099,6 +38887,10 @@
             <a:prstDash val="solid"/>
           </a:ln>
         </p:spPr>
+        <p:txBody>
+          <a:bodyPr/>
+          <a:p/>
+        </p:txBody>
       </p:sp>
       <p:sp>
         <p:nvSpPr>
@@ -37165,6 +38957,10 @@
             <a:prstDash val="solid"/>
           </a:ln>
         </p:spPr>
+        <p:txBody>
+          <a:bodyPr/>
+          <a:p/>
+        </p:txBody>
       </p:sp>
       <p:sp>
         <p:nvSpPr>
@@ -37231,6 +39027,10 @@
             <a:prstDash val="solid"/>
           </a:ln>
         </p:spPr>
+        <p:txBody>
+          <a:bodyPr/>
+          <a:p/>
+        </p:txBody>
       </p:sp>
       <p:sp>
         <p:nvSpPr>
@@ -37297,6 +39097,10 @@
             <a:prstDash val="solid"/>
           </a:ln>
         </p:spPr>
+        <p:txBody>
+          <a:bodyPr/>
+          <a:p/>
+        </p:txBody>
       </p:sp>
       <p:sp>
         <p:nvSpPr>
@@ -37363,6 +39167,10 @@
             <a:prstDash val="solid"/>
           </a:ln>
         </p:spPr>
+        <p:txBody>
+          <a:bodyPr/>
+          <a:p/>
+        </p:txBody>
       </p:sp>
       <p:sp>
         <p:nvSpPr>
@@ -37429,6 +39237,10 @@
             <a:prstDash val="solid"/>
           </a:ln>
         </p:spPr>
+        <p:txBody>
+          <a:bodyPr/>
+          <a:p/>
+        </p:txBody>
       </p:sp>
       <p:sp>
         <p:nvSpPr>
@@ -37492,6 +39304,10 @@
             <a:tailEnd type="triangle"/>
           </a:ln>
         </p:spPr>
+        <p:txBody>
+          <a:bodyPr/>
+          <a:p/>
+        </p:txBody>
       </p:sp>
       <p:sp>
         <p:nvSpPr>
@@ -37516,6 +39332,10 @@
             <a:tailEnd type="triangle"/>
           </a:ln>
         </p:spPr>
+        <p:txBody>
+          <a:bodyPr/>
+          <a:p/>
+        </p:txBody>
       </p:sp>
       <p:sp>
         <p:nvSpPr>
@@ -37540,6 +39360,10 @@
             <a:tailEnd type="triangle"/>
           </a:ln>
         </p:spPr>
+        <p:txBody>
+          <a:bodyPr/>
+          <a:p/>
+        </p:txBody>
       </p:sp>
       <p:sp>
         <p:nvSpPr>
@@ -37564,6 +39388,10 @@
             <a:tailEnd type="triangle"/>
           </a:ln>
         </p:spPr>
+        <p:txBody>
+          <a:bodyPr/>
+          <a:p/>
+        </p:txBody>
       </p:sp>
       <p:sp>
         <p:nvSpPr>
@@ -37588,6 +39416,10 @@
             <a:tailEnd type="triangle"/>
           </a:ln>
         </p:spPr>
+        <p:txBody>
+          <a:bodyPr/>
+          <a:p/>
+        </p:txBody>
       </p:sp>
       <p:sp>
         <p:nvSpPr>
@@ -37612,6 +39444,10 @@
             <a:tailEnd type="triangle"/>
           </a:ln>
         </p:spPr>
+        <p:txBody>
+          <a:bodyPr/>
+          <a:p/>
+        </p:txBody>
       </p:sp>
       <p:sp>
         <p:nvSpPr>
@@ -37678,6 +39514,10 @@
             <a:prstDash val="solid"/>
           </a:ln>
         </p:spPr>
+        <p:txBody>
+          <a:bodyPr/>
+          <a:p/>
+        </p:txBody>
       </p:sp>
       <p:pic>
         <p:nvPicPr>
@@ -37742,6 +39582,30 @@
           </a:p>
         </p:txBody>
       </p:sp>
+      <p:pic>
+        <p:nvPicPr>
+          <p:cNvPr id="42" name="IE University logo" descr="IE University, School of Science &amp; Technology"/>
+          <p:cNvPicPr>
+            <a:picLocks noChangeAspect="1"/>
+          </p:cNvPicPr>
+          <p:nvPr/>
+        </p:nvPicPr>
+        <p:blipFill>
+          <a:blip r:embed="rId7"/>
+          <a:stretch>
+            <a:fillRect/>
+          </a:stretch>
+        </p:blipFill>
+        <p:spPr>
+          <a:xfrm>
+            <a:off x="8013607" y="92634"/>
+            <a:ext cx="764633" cy="262789"/>
+          </a:xfrm>
+          <a:prstGeom prst="rect">
+            <a:avLst/>
+          </a:prstGeom>
+        </p:spPr>
+      </p:pic>
     </p:spTree>
   </p:cSld>
   <p:clrMapOvr>
@@ -37807,7 +39671,7 @@
                 <a:ea typeface="Calibri" pitchFamily="34" charset="-122"/>
                 <a:cs typeface="Calibri" pitchFamily="34" charset="-120"/>
               </a:rPr>
-              <a:t>Master in Business Analytics and Big Data</a:t>
+              <a:t>Master in Business Analytics and Data Science</a:t>
             </a:r>
             <a:endParaRPr lang="en-US" sz="900" dirty="0"/>
           </a:p>
@@ -37846,7 +39710,7 @@
                 <a:ea typeface="Calibri" pitchFamily="34" charset="-122"/>
                 <a:cs typeface="Calibri" pitchFamily="34" charset="-120"/>
               </a:rPr>
-              <a:t>MLOps · MBABD-PT 2026–27 · Session 3 · Juan Ramírez</a:t>
+              <a:t>MLOps · MBDS-PT2026F · Session 3 · Juan Ramírez</a:t>
             </a:r>
             <a:endParaRPr lang="en-US" sz="800" dirty="0"/>
           </a:p>
@@ -37995,6 +39859,10 @@
             <a:prstDash val="solid"/>
           </a:ln>
         </p:spPr>
+        <p:txBody>
+          <a:bodyPr/>
+          <a:p/>
+        </p:txBody>
       </p:sp>
       <p:sp>
         <p:nvSpPr>
@@ -38061,6 +39929,10 @@
             <a:prstDash val="solid"/>
           </a:ln>
         </p:spPr>
+        <p:txBody>
+          <a:bodyPr/>
+          <a:p/>
+        </p:txBody>
       </p:sp>
       <p:sp>
         <p:nvSpPr>
@@ -38127,6 +39999,10 @@
             <a:prstDash val="solid"/>
           </a:ln>
         </p:spPr>
+        <p:txBody>
+          <a:bodyPr/>
+          <a:p/>
+        </p:txBody>
       </p:sp>
       <p:sp>
         <p:nvSpPr>
@@ -38193,6 +40069,10 @@
             <a:prstDash val="solid"/>
           </a:ln>
         </p:spPr>
+        <p:txBody>
+          <a:bodyPr/>
+          <a:p/>
+        </p:txBody>
       </p:sp>
       <p:sp>
         <p:nvSpPr>
@@ -38259,6 +40139,10 @@
             <a:prstDash val="solid"/>
           </a:ln>
         </p:spPr>
+        <p:txBody>
+          <a:bodyPr/>
+          <a:p/>
+        </p:txBody>
       </p:sp>
       <p:sp>
         <p:nvSpPr>
@@ -38325,6 +40209,10 @@
             <a:prstDash val="solid"/>
           </a:ln>
         </p:spPr>
+        <p:txBody>
+          <a:bodyPr/>
+          <a:p/>
+        </p:txBody>
       </p:sp>
       <p:sp>
         <p:nvSpPr>
@@ -38391,6 +40279,10 @@
             <a:prstDash val="solid"/>
           </a:ln>
         </p:spPr>
+        <p:txBody>
+          <a:bodyPr/>
+          <a:p/>
+        </p:txBody>
       </p:sp>
       <p:sp>
         <p:nvSpPr>
@@ -38457,6 +40349,10 @@
             <a:prstDash val="solid"/>
           </a:ln>
         </p:spPr>
+        <p:txBody>
+          <a:bodyPr/>
+          <a:p/>
+        </p:txBody>
       </p:sp>
       <p:sp>
         <p:nvSpPr>
@@ -38523,6 +40419,10 @@
             <a:prstDash val="solid"/>
           </a:ln>
         </p:spPr>
+        <p:txBody>
+          <a:bodyPr/>
+          <a:p/>
+        </p:txBody>
       </p:sp>
       <p:sp>
         <p:nvSpPr>
@@ -38602,6 +40502,30 @@
           </a:p>
         </p:txBody>
       </p:sp>
+      <p:pic>
+        <p:nvPicPr>
+          <p:cNvPr id="26" name="IE University logo" descr="IE University, School of Science &amp; Technology"/>
+          <p:cNvPicPr>
+            <a:picLocks noChangeAspect="1"/>
+          </p:cNvPicPr>
+          <p:nvPr/>
+        </p:nvPicPr>
+        <p:blipFill>
+          <a:blip r:embed="rId3"/>
+          <a:stretch>
+            <a:fillRect/>
+          </a:stretch>
+        </p:blipFill>
+        <p:spPr>
+          <a:xfrm>
+            <a:off x="8252653" y="109728"/>
+            <a:ext cx="525587" cy="704395"/>
+          </a:xfrm>
+          <a:prstGeom prst="rect">
+            <a:avLst/>
+          </a:prstGeom>
+        </p:spPr>
+      </p:pic>
     </p:spTree>
   </p:cSld>
   <p:clrMapOvr>

</xml_diff>

<commit_message>
S03: fix EU AI Act fraud exclusion, slide 13 note, MLflow offline backup
</commit_message>
<xml_diff>
--- a/2026-27/S03/MLOps_S03_Pipelines_Environments_Security.pptx
+++ b/2026-27/S03/MLOps_S03_Pipelines_Environments_Security.pptx
@@ -900,7 +900,7 @@
             <a:r>
               <a:rPr lang="en-US" dirty="0"/>
               <a:t>Why validation is the most important checkpoint: it catches changes in the incoming data before the expensive pre-processing and training steps, and before a bad model is deployed. Three checks: anomalies (impossible values, empty columns, duplicates); schema (the columns, types and ranges are what we expect); statistics (the new dataset still looks like the previous training datasets: same distribution, roughly).
-Callback: NorthRetail's empty product-code features and the demo repository's "Fix" commit are check 1 and check 2. The 60%-empty extract you will see in MLflow is check 3 failing while the accuracy metric barely moved.
+Callback: NorthRetail's empty product-code features and the demo repository's "Fix" commit are check 1 and check 2. The 60%-empty extract you will see in MLflow is check 1 (anomalies) catching what the accuracy metric barely showed.
 Tools exist (TensorFlow Data Validation, Great Expectations, Evidently); name them, do not show them.
 Timing: minute 22–25.</a:t>
             </a:r>
@@ -2246,7 +2246,7 @@
             <a:r>
               <a:rPr lang="en-US" dirty="0"/>
               <a:t>Brief before sending them to rooms; the brief and the case are on campus.
-Every room gets the same one-page case: IberBank's card-fraud model, with three incidents from last year: a data-integrity incident, an adversarial incident and an environment incident. For each, they fill a row of the blueprint: threat, lifecycle stage where it enters, one control, who owns the control, how you would detect the threat (which lineage or monitoring signal). Bonus: which of the three would the EU AI Act care about most, and why (a preview of Session 12).
+Every room gets the same one-page case: IberBank's card-fraud model, with three incidents from last year: a data-integrity incident, an adversarial incident and an environment incident. For each, they fill a row of the blueprint: threat, lifecycle stage where it enters, one control, who owns the control, how you would detect the threat (which lineage or monitoring signal). Bonus: which of the three would a financial regulator care about most, and why (a preview of Session 12).
 Output: one slide or whiteboard; spokesperson; three rooms present.
 Timing: brief 58–60; case 60–61; rooms 61–76; debrief 76–86.</a:t>
             </a:r>
@@ -2426,7 +2426,7 @@
               <a:rPr lang="en-US" dirty="0"/>
               <a:t>Three rooms present (76–82), then four minutes of synthesis with this slide (82–86).
 Expected: Incident 1, integrity → enters at data ingestion/validation → control: schema and range validation on the feed plus a contract with the vendor → owner: data engineer → detection: validation report per span, a spike in blocked transactions per merchant. Incident 2, adversarial evasion → enters at inference (model feedback) → control: monitoring for probing patterns (many small transactions just under a threshold), never a fixed public threshold, retrain on discovered patterns → owner: ML engineer with the fraud team → detection: transaction patterns by merchant and amount band, chargebacks arriving 60 days later confirm. Incident 3, environment → enters at deployment → control: the two gates: no promotion from a laptop, QA sign-off, a versioned artefact and rollback → owner: product owner accountable, ML engineer responsible, IT enforcing → detection: lineage shows a change without a QA record; false-positive rate over the weekend.
-Bonus: the regulator cares most about incident 3 (no human oversight, no record) and about false blocks affecting customers (incident 1); the EU AI Act treats credit and fraud decisions affecting people as high risk. Session 12.
+Bonus: the regulator cares most about incident 3 (no human oversight, no record) and about false blocks affecting customers (incident 1). Careful with the EU AI Act: it lists credit scoring as high-risk but explicitly excludes fraud detection (Annex III, point 5(b)), so this model is not high-risk under the Act. The pressure here comes from banking supervisors (model-risk and IT-change controls) and from GDPR's safeguards for automated decisions that significantly affect people. Session 12.
 Close: "Every control you named is a step in the pipeline or a gate between environments. That is what MLOps is."
 Timing: minute 76–86.</a:t>
             </a:r>

</xml_diff>

<commit_message>
Fix duplicate shape IDs that triggered PowerPoint repair (S03, S05, S07, S09, S10, S12)
</commit_message>
<xml_diff>
--- a/2026-27/S03/MLOps_S03_Pipelines_Environments_Security.pptx
+++ b/2026-27/S03/MLOps_S03_Pipelines_Environments_Security.pptx
@@ -1441,6 +1441,7 @@
               <a:rPr lang="en-US" dirty="0"/>
               <a:t>The recurring diagram of this session. Dev: where data scientists and engineers build; anything goes; sample data, may be broken. QA (also called staging or pre-production): a copy of production, same infrastructure, same data shapes, where the model is tested as if live, with no real customers. Prod: real customers, real money; only what passed QA gets in.
 The two gates matter more than the three boxes. Gate 1 (Dev → QA): tests pass, data validated, model registered with a version. Gate 2 (QA → Prod): behaves like production (latency, load), sign-off by the accountable owner, rollback plan. Who can promote: not the person who built it.
+Forum 1 callback: answer Julio M.'s open question here. Does a model retrained after drift go back through validation? Yes: a retrained model is a new version, so it passes Gate 1 and Gate 2 like any other. Otherwise, as the synthesis said, the ML engineer is approving a new model alone.
 Timing: minute 38–41.</a:t>
             </a:r>
             <a:endParaRPr lang="en-US" dirty="0"/>
@@ -1529,7 +1530,7 @@
           <a:p>
             <a:r>
               <a:rPr lang="en-US" dirty="0"/>
-              <a:t>Left column: two or three quotes from the Forum 1 synthesis (paste them into the slide on Friday night; the placeholders are there). Read one, name the author, thank them. Then the outcomes.
+              <a:t>Left column: two quotes from the Forum 1 synthesis. Read Marcos's aloud and thank him: it is Session 1's key idea in his words. Then Armen's, and add Khem's longer version of the same point: “the platform can be 100% up while every order proposal is wrong” (infrastructure health is not model health; Session 7 returns to it). The misconception of the week matches your Friday synthesis: operationalising is not “putting it on a server”; it means today's data, an output that lands where a decision is made, and a named person accountable. Two reminders: Julio M.'s open question (does a retrained model go back through validation?) is answered on slide 19; and declare AI use on every forum post, replies included. Then the outcomes.
 Right column: the agenda. Same shape as last week: concept blocks, a demo, a poll, break, one breakout, debrief.
 Timing: minute 2–4.</a:t>
             </a:r>
@@ -14669,7 +14670,7 @@
                 <a:ea typeface="Calibri" pitchFamily="34" charset="-122"/>
                 <a:cs typeface="Calibri" pitchFamily="34" charset="-120"/>
               </a:rPr>
-              <a:t>From Forum 1 (paste 2–3 quotes on Friday)</a:t>
+              <a:t>From Forum 1</a:t>
             </a:r>
             <a:endParaRPr lang="en-US" sz="1300" dirty="0"/>
           </a:p>
@@ -14782,7 +14783,7 @@
                 <a:ea typeface="Calibri" pitchFamily="34" charset="-122"/>
                 <a:cs typeface="Calibri" pitchFamily="34" charset="-120"/>
               </a:rPr>
-              <a:t>"…" — [student]</a:t>
+              <a:t>“A trained model is a result; an operational model is a service.” — Marcos</a:t>
             </a:r>
             <a:endParaRPr lang="en-US" sz="1100" dirty="0"/>
           </a:p>
@@ -14803,7 +14804,7 @@
                 <a:ea typeface="Calibri" pitchFamily="34" charset="-122"/>
                 <a:cs typeface="Calibri" pitchFamily="34" charset="-120"/>
               </a:rPr>
-              <a:t>"…" — [student]</a:t>
+              <a:t>“Green means up, not right.” — Armen</a:t>
             </a:r>
             <a:endParaRPr lang="en-US" sz="1100" dirty="0"/>
           </a:p>
@@ -14824,7 +14825,7 @@
                 <a:ea typeface="Calibri" pitchFamily="34" charset="-122"/>
                 <a:cs typeface="Calibri" pitchFamily="34" charset="-120"/>
               </a:rPr>
-              <a:t>Misconception of the week: operationalising = "putting it on a server"</a:t>
+              <a:t>Misconception of the week: operationalising = “putting it on a server”</a:t>
             </a:r>
             <a:endParaRPr lang="en-US" sz="1100" dirty="0"/>
           </a:p>
@@ -15133,7 +15134,7 @@
       </p:sp>
       <p:graphicFrame>
         <p:nvGraphicFramePr>
-          <p:cNvPr id="3" name="Table 0"/>
+          <p:cNvPr id="21" name="Table 0"/>
           <p:cNvGraphicFramePr>
             <a:graphicFrameLocks noGrp="1"/>
           </p:cNvGraphicFramePr>
@@ -33207,7 +33208,7 @@
       </p:sp>
       <p:graphicFrame>
         <p:nvGraphicFramePr>
-          <p:cNvPr id="5" name="Table 0"/>
+          <p:cNvPr id="14" name="Table 0"/>
           <p:cNvGraphicFramePr>
             <a:graphicFrameLocks noGrp="1"/>
           </p:cNvGraphicFramePr>

</xml_diff>

<commit_message>
Forum 2: optional MLflow lab (Theme A), all themes optional, posting plan; S03 refs updated
</commit_message>
<xml_diff>
--- a/2026-27/S03/MLOps_S03_Pipelines_Environments_Security.pptx
+++ b/2026-27/S03/MLOps_S03_Pipelines_Environments_Security.pptx
@@ -1390,7 +1390,7 @@
             <a:r>
               <a:rPr lang="en-US" dirty="0"/>
               <a:t>Forum 2, question 2, in one slide. Six things, each of which has happened somewhere: the laptop had a library version that production does not; the pre-processing was in cells that were not shipped; nobody tested the latency under load; the data scientist used a test file, not the live feed; there is no version, so there is nothing to roll back to; and nobody signed off, so nobody is accountable.
-Then the chat poll (2 minutes): the statement on screen. Read two contrasting answers. Do not resolve; send it to Forum 2 Theme A ("skip QA to hit the launch date"). The honest answer: sometimes yes, for a low-risk internal model, with a named owner and a rollback plan; never for a customer-facing model.
+Then the chat poll (2 minutes): the statement on screen. Read two contrasting answers. Do not resolve; send it to Forum 2 Optional Theme B ("skip QA to hit the launch date"). The honest answer: sometimes yes, for a low-risk internal model, with a named owner and a rollback plan; never for a customer-facing model.
 Timing: minute 41–44.</a:t>
             </a:r>
           </a:p>
@@ -2452,7 +2452,7 @@
           <a:p>
             <a:r>
               <a:rPr lang="en-US" dirty="0"/>
-              <a:t>Read the three questions; verbatim from the syllabus. Point to where each was covered: Q1 = the notebook-vs-pipeline slide and the lifecycle; Q2 = the three-environments slide and the laptop-to-production slide; Q3 = the four attacks, the controls and the lineage slide. The poll from earlier is Theme A.
+              <a:t>Read the three questions; verbatim from the syllabus. Point to where each was covered: Q1 = the notebook-vs-pipeline slide and the lifecycle; Q2 = the three-environments slide and the laptop-to-production slide; Q3 = the four attacks, the controls and the lineage slide. The poll from earlier is Optional Theme B (all themes are optional).
 Timing: minute 87–89.</a:t>
             </a:r>
           </a:p>

</xml_diff>